<commit_message>
docs: finalize competition-grade 8-slide deck with architecture & workflows
</commit_message>
<xml_diff>
--- a/docs/Hacktoberfest_Copilot_Round2_Presentation.pptx
+++ b/docs/Hacktoberfest_Copilot_Round2_Presentation.pptx
@@ -6,13 +6,13 @@
   </p:sldMasterIdLst>
   <p:sldIdLst>
     <p:sldId id="256" r:id="rId7"/>
-    <p:sldId id="257" r:id="rId8"/>
-    <p:sldId id="258" r:id="rId9"/>
-    <p:sldId id="259" r:id="rId10"/>
-    <p:sldId id="260" r:id="rId11"/>
-    <p:sldId id="261" r:id="rId12"/>
-    <p:sldId id="262" r:id="rId13"/>
-    <p:sldId id="263" r:id="rId14"/>
+    <p:sldId id="257" r:id="rId9"/>
+    <p:sldId id="258" r:id="rId10"/>
+    <p:sldId id="259" r:id="rId11"/>
+    <p:sldId id="260" r:id="rId12"/>
+    <p:sldId id="261" r:id="rId13"/>
+    <p:sldId id="262" r:id="rId14"/>
+    <p:sldId id="263" r:id="rId15"/>
   </p:sldIdLst>
   <p:sldSz cx="12191695" cy="6858000" type="screen4x3"/>
   <p:notesSz cx="6858000" cy="9144000"/>
@@ -112,6 +112,1051 @@
     </a:lvl9pPr>
   </p:defaultTextStyle>
 </p:presentation>
+</file>
+
+<file path=ppt/notesMasters/notesMaster1.xml><?xml version="1.0" encoding="utf-8"?>
+<p:notesMaster xmlns:a="http://schemas.openxmlformats.org/drawingml/2006/main" xmlns:p="http://schemas.openxmlformats.org/presentationml/2006/main" xmlns:r="http://schemas.openxmlformats.org/officeDocument/2006/relationships">
+  <p:cSld>
+    <p:bg>
+      <p:bgRef idx="1001">
+        <a:schemeClr val="bg1"/>
+      </p:bgRef>
+    </p:bg>
+    <p:spTree>
+      <p:nvGrpSpPr>
+        <p:cNvPr id="1" name=""/>
+        <p:cNvGrpSpPr/>
+        <p:nvPr/>
+      </p:nvGrpSpPr>
+      <p:grpSpPr>
+        <a:xfrm>
+          <a:off x="0" y="0"/>
+          <a:ext cx="0" cy="0"/>
+          <a:chOff x="0" y="0"/>
+          <a:chExt cx="0" cy="0"/>
+        </a:xfrm>
+      </p:grpSpPr>
+      <p:sp>
+        <p:nvSpPr>
+          <p:cNvPr id="2" name="Header Placeholder 1"/>
+          <p:cNvSpPr>
+            <a:spLocks noGrp="1"/>
+          </p:cNvSpPr>
+          <p:nvPr>
+            <p:ph type="hdr" sz="quarter"/>
+          </p:nvPr>
+        </p:nvSpPr>
+        <p:spPr>
+          <a:xfrm>
+            <a:off x="0" y="0"/>
+            <a:ext cx="2971800" cy="457200"/>
+          </a:xfrm>
+          <a:prstGeom prst="rect">
+            <a:avLst/>
+          </a:prstGeom>
+        </p:spPr>
+        <p:txBody>
+          <a:bodyPr vert="horz" lIns="91440" tIns="45720" rIns="91440" bIns="45720" rtlCol="0"/>
+          <a:lstStyle>
+            <a:lvl1pPr algn="l">
+              <a:defRPr sz="1200"/>
+            </a:lvl1pPr>
+          </a:lstStyle>
+          <a:p>
+            <a:endParaRPr lang="en-US"/>
+          </a:p>
+        </p:txBody>
+      </p:sp>
+      <p:sp>
+        <p:nvSpPr>
+          <p:cNvPr id="3" name="Date Placeholder 2"/>
+          <p:cNvSpPr>
+            <a:spLocks noGrp="1"/>
+          </p:cNvSpPr>
+          <p:nvPr>
+            <p:ph type="dt" idx="1"/>
+          </p:nvPr>
+        </p:nvSpPr>
+        <p:spPr>
+          <a:xfrm>
+            <a:off x="3884613" y="0"/>
+            <a:ext cx="2971800" cy="457200"/>
+          </a:xfrm>
+          <a:prstGeom prst="rect">
+            <a:avLst/>
+          </a:prstGeom>
+        </p:spPr>
+        <p:txBody>
+          <a:bodyPr vert="horz" lIns="91440" tIns="45720" rIns="91440" bIns="45720" rtlCol="0"/>
+          <a:lstStyle>
+            <a:lvl1pPr algn="r">
+              <a:defRPr sz="1200"/>
+            </a:lvl1pPr>
+          </a:lstStyle>
+          <a:p>
+            <a:fld id="{0F89C1C7-3DCD-1040-A9CF-14679D8B5DDD}" type="datetimeFigureOut">
+              <a:rPr lang="en-US" smtClean="0"/>
+              <a:t>10/17/16</a:t>
+            </a:fld>
+            <a:endParaRPr lang="en-US"/>
+          </a:p>
+        </p:txBody>
+      </p:sp>
+      <p:sp>
+        <p:nvSpPr>
+          <p:cNvPr id="4" name="Slide Image Placeholder 3"/>
+          <p:cNvSpPr>
+            <a:spLocks noGrp="1" noRot="1" noChangeAspect="1"/>
+          </p:cNvSpPr>
+          <p:nvPr>
+            <p:ph type="sldImg" idx="2"/>
+          </p:nvPr>
+        </p:nvSpPr>
+        <p:spPr>
+          <a:xfrm>
+            <a:off x="1143000" y="685800"/>
+            <a:ext cx="4572000" cy="3429000"/>
+          </a:xfrm>
+          <a:prstGeom prst="rect">
+            <a:avLst/>
+          </a:prstGeom>
+          <a:noFill/>
+          <a:ln w="12700">
+            <a:solidFill>
+              <a:prstClr val="black"/>
+            </a:solidFill>
+          </a:ln>
+        </p:spPr>
+        <p:txBody>
+          <a:bodyPr vert="horz" lIns="91440" tIns="45720" rIns="91440" bIns="45720" rtlCol="0" anchor="ctr"/>
+          <a:lstStyle/>
+          <a:p>
+            <a:endParaRPr lang="en-US"/>
+          </a:p>
+        </p:txBody>
+      </p:sp>
+      <p:sp>
+        <p:nvSpPr>
+          <p:cNvPr id="5" name="Notes Placeholder 4"/>
+          <p:cNvSpPr>
+            <a:spLocks noGrp="1"/>
+          </p:cNvSpPr>
+          <p:nvPr>
+            <p:ph type="body" sz="quarter" idx="3"/>
+          </p:nvPr>
+        </p:nvSpPr>
+        <p:spPr>
+          <a:xfrm>
+            <a:off x="685800" y="4343400"/>
+            <a:ext cx="5486400" cy="4114800"/>
+          </a:xfrm>
+          <a:prstGeom prst="rect">
+            <a:avLst/>
+          </a:prstGeom>
+        </p:spPr>
+        <p:txBody>
+          <a:bodyPr vert="horz" lIns="91440" tIns="45720" rIns="91440" bIns="45720" rtlCol="0"/>
+          <a:lstStyle/>
+          <a:p>
+            <a:pPr lvl="0"/>
+            <a:r>
+              <a:rPr lang="en-US" smtClean="0"/>
+              <a:t>Click to edit Master text styles</a:t>
+            </a:r>
+          </a:p>
+          <a:p>
+            <a:pPr lvl="1"/>
+            <a:r>
+              <a:rPr lang="en-US" smtClean="0"/>
+              <a:t>Second level</a:t>
+            </a:r>
+          </a:p>
+          <a:p>
+            <a:pPr lvl="2"/>
+            <a:r>
+              <a:rPr lang="en-US" smtClean="0"/>
+              <a:t>Third level</a:t>
+            </a:r>
+          </a:p>
+          <a:p>
+            <a:pPr lvl="3"/>
+            <a:r>
+              <a:rPr lang="en-US" smtClean="0"/>
+              <a:t>Fourth level</a:t>
+            </a:r>
+          </a:p>
+          <a:p>
+            <a:pPr lvl="4"/>
+            <a:r>
+              <a:rPr lang="en-US" smtClean="0"/>
+              <a:t>Fifth level</a:t>
+            </a:r>
+            <a:endParaRPr lang="en-US"/>
+          </a:p>
+        </p:txBody>
+      </p:sp>
+      <p:sp>
+        <p:nvSpPr>
+          <p:cNvPr id="6" name="Footer Placeholder 5"/>
+          <p:cNvSpPr>
+            <a:spLocks noGrp="1"/>
+          </p:cNvSpPr>
+          <p:nvPr>
+            <p:ph type="ftr" sz="quarter" idx="4"/>
+          </p:nvPr>
+        </p:nvSpPr>
+        <p:spPr>
+          <a:xfrm>
+            <a:off x="0" y="8685213"/>
+            <a:ext cx="2971800" cy="457200"/>
+          </a:xfrm>
+          <a:prstGeom prst="rect">
+            <a:avLst/>
+          </a:prstGeom>
+        </p:spPr>
+        <p:txBody>
+          <a:bodyPr vert="horz" lIns="91440" tIns="45720" rIns="91440" bIns="45720" rtlCol="0" anchor="b"/>
+          <a:lstStyle>
+            <a:lvl1pPr algn="l">
+              <a:defRPr sz="1200"/>
+            </a:lvl1pPr>
+          </a:lstStyle>
+          <a:p>
+            <a:endParaRPr lang="en-US"/>
+          </a:p>
+        </p:txBody>
+      </p:sp>
+      <p:sp>
+        <p:nvSpPr>
+          <p:cNvPr id="7" name="Slide Number Placeholder 6"/>
+          <p:cNvSpPr>
+            <a:spLocks noGrp="1"/>
+          </p:cNvSpPr>
+          <p:nvPr>
+            <p:ph type="sldNum" sz="quarter" idx="5"/>
+          </p:nvPr>
+        </p:nvSpPr>
+        <p:spPr>
+          <a:xfrm>
+            <a:off x="3884613" y="8685213"/>
+            <a:ext cx="2971800" cy="457200"/>
+          </a:xfrm>
+          <a:prstGeom prst="rect">
+            <a:avLst/>
+          </a:prstGeom>
+        </p:spPr>
+        <p:txBody>
+          <a:bodyPr vert="horz" lIns="91440" tIns="45720" rIns="91440" bIns="45720" rtlCol="0" anchor="b"/>
+          <a:lstStyle>
+            <a:lvl1pPr algn="r">
+              <a:defRPr sz="1200"/>
+            </a:lvl1pPr>
+          </a:lstStyle>
+          <a:p>
+            <a:fld id="{BB5E49A5-4136-284D-997B-48E1D791AD67}" type="slidenum">
+              <a:rPr lang="en-US" smtClean="0"/>
+              <a:t>‹#›</a:t>
+            </a:fld>
+            <a:endParaRPr lang="en-US"/>
+          </a:p>
+        </p:txBody>
+      </p:sp>
+    </p:spTree>
+    <p:extLst>
+      <p:ext uri="{BB962C8B-B14F-4D97-AF65-F5344CB8AC3E}">
+        <p14:creationId xmlns:p14="http://schemas.microsoft.com/office/powerpoint/2010/main" val="2623252185"/>
+      </p:ext>
+    </p:extLst>
+  </p:cSld>
+  <p:clrMap bg1="lt1" tx1="dk1" bg2="lt2" tx2="dk2" accent1="accent1" accent2="accent2" accent3="accent3" accent4="accent4" accent5="accent5" accent6="accent6" hlink="hlink" folHlink="folHlink"/>
+  <p:notesStyle>
+    <a:lvl1pPr marL="0" algn="l" defTabSz="457200" rtl="0" eaLnBrk="1" latinLnBrk="0" hangingPunct="1">
+      <a:defRPr sz="1200" kern="1200">
+        <a:solidFill>
+          <a:schemeClr val="tx1"/>
+        </a:solidFill>
+        <a:latin typeface="+mn-lt"/>
+        <a:ea typeface="+mn-ea"/>
+        <a:cs typeface="+mn-cs"/>
+      </a:defRPr>
+    </a:lvl1pPr>
+    <a:lvl2pPr marL="457200" algn="l" defTabSz="457200" rtl="0" eaLnBrk="1" latinLnBrk="0" hangingPunct="1">
+      <a:defRPr sz="1200" kern="1200">
+        <a:solidFill>
+          <a:schemeClr val="tx1"/>
+        </a:solidFill>
+        <a:latin typeface="+mn-lt"/>
+        <a:ea typeface="+mn-ea"/>
+        <a:cs typeface="+mn-cs"/>
+      </a:defRPr>
+    </a:lvl2pPr>
+    <a:lvl3pPr marL="914400" algn="l" defTabSz="457200" rtl="0" eaLnBrk="1" latinLnBrk="0" hangingPunct="1">
+      <a:defRPr sz="1200" kern="1200">
+        <a:solidFill>
+          <a:schemeClr val="tx1"/>
+        </a:solidFill>
+        <a:latin typeface="+mn-lt"/>
+        <a:ea typeface="+mn-ea"/>
+        <a:cs typeface="+mn-cs"/>
+      </a:defRPr>
+    </a:lvl3pPr>
+    <a:lvl4pPr marL="1371600" algn="l" defTabSz="457200" rtl="0" eaLnBrk="1" latinLnBrk="0" hangingPunct="1">
+      <a:defRPr sz="1200" kern="1200">
+        <a:solidFill>
+          <a:schemeClr val="tx1"/>
+        </a:solidFill>
+        <a:latin typeface="+mn-lt"/>
+        <a:ea typeface="+mn-ea"/>
+        <a:cs typeface="+mn-cs"/>
+      </a:defRPr>
+    </a:lvl4pPr>
+    <a:lvl5pPr marL="1828800" algn="l" defTabSz="457200" rtl="0" eaLnBrk="1" latinLnBrk="0" hangingPunct="1">
+      <a:defRPr sz="1200" kern="1200">
+        <a:solidFill>
+          <a:schemeClr val="tx1"/>
+        </a:solidFill>
+        <a:latin typeface="+mn-lt"/>
+        <a:ea typeface="+mn-ea"/>
+        <a:cs typeface="+mn-cs"/>
+      </a:defRPr>
+    </a:lvl5pPr>
+    <a:lvl6pPr marL="2286000" algn="l" defTabSz="457200" rtl="0" eaLnBrk="1" latinLnBrk="0" hangingPunct="1">
+      <a:defRPr sz="1200" kern="1200">
+        <a:solidFill>
+          <a:schemeClr val="tx1"/>
+        </a:solidFill>
+        <a:latin typeface="+mn-lt"/>
+        <a:ea typeface="+mn-ea"/>
+        <a:cs typeface="+mn-cs"/>
+      </a:defRPr>
+    </a:lvl6pPr>
+    <a:lvl7pPr marL="2743200" algn="l" defTabSz="457200" rtl="0" eaLnBrk="1" latinLnBrk="0" hangingPunct="1">
+      <a:defRPr sz="1200" kern="1200">
+        <a:solidFill>
+          <a:schemeClr val="tx1"/>
+        </a:solidFill>
+        <a:latin typeface="+mn-lt"/>
+        <a:ea typeface="+mn-ea"/>
+        <a:cs typeface="+mn-cs"/>
+      </a:defRPr>
+    </a:lvl7pPr>
+    <a:lvl8pPr marL="3200400" algn="l" defTabSz="457200" rtl="0" eaLnBrk="1" latinLnBrk="0" hangingPunct="1">
+      <a:defRPr sz="1200" kern="1200">
+        <a:solidFill>
+          <a:schemeClr val="tx1"/>
+        </a:solidFill>
+        <a:latin typeface="+mn-lt"/>
+        <a:ea typeface="+mn-ea"/>
+        <a:cs typeface="+mn-cs"/>
+      </a:defRPr>
+    </a:lvl8pPr>
+    <a:lvl9pPr marL="3657600" algn="l" defTabSz="457200" rtl="0" eaLnBrk="1" latinLnBrk="0" hangingPunct="1">
+      <a:defRPr sz="1200" kern="1200">
+        <a:solidFill>
+          <a:schemeClr val="tx1"/>
+        </a:solidFill>
+        <a:latin typeface="+mn-lt"/>
+        <a:ea typeface="+mn-ea"/>
+        <a:cs typeface="+mn-cs"/>
+      </a:defRPr>
+    </a:lvl9pPr>
+  </p:notesStyle>
+</p:notesMaster>
+</file>
+
+<file path=ppt/notesSlides/notesSlide1.xml><?xml version="1.0" encoding="utf-8"?>
+<p:notes xmlns:a="http://schemas.openxmlformats.org/drawingml/2006/main" xmlns:p="http://schemas.openxmlformats.org/presentationml/2006/main" xmlns:r="http://schemas.openxmlformats.org/officeDocument/2006/relationships">
+  <p:cSld>
+    <p:spTree>
+      <p:nvGrpSpPr>
+        <p:cNvPr id="1" name=""/>
+        <p:cNvGrpSpPr/>
+        <p:nvPr/>
+      </p:nvGrpSpPr>
+      <p:grpSpPr>
+        <a:xfrm>
+          <a:off x="0" y="0"/>
+          <a:ext cx="0" cy="0"/>
+          <a:chOff x="0" y="0"/>
+          <a:chExt cx="0" cy="0"/>
+        </a:xfrm>
+      </p:grpSpPr>
+      <p:sp>
+        <p:nvSpPr>
+          <p:cNvPr id="2" name="Slide Image Placeholder 1"/>
+          <p:cNvSpPr>
+            <a:spLocks noGrp="1"/>
+          </p:cNvSpPr>
+          <p:nvPr>
+            <p:ph type="sldImg" idx="2"/>
+          </p:nvPr>
+        </p:nvSpPr>
+        <p:spPr/>
+      </p:sp>
+      <p:sp>
+        <p:nvSpPr>
+          <p:cNvPr id="3" name="Notes Placeholder 2"/>
+          <p:cNvSpPr>
+            <a:spLocks noGrp="1"/>
+          </p:cNvSpPr>
+          <p:nvPr>
+            <p:ph type="body" idx="3" sz="quarter"/>
+          </p:nvPr>
+        </p:nvSpPr>
+        <p:spPr/>
+        <p:txBody>
+          <a:bodyPr/>
+          <a:lstStyle/>
+          <a:p>
+            <a:r>
+              <a:t>Slide 1 Notes (0:00 - 0:30):</a:t>
+            </a:r>
+          </a:p>
+          <a:p>
+            <a:r>
+              <a:t>- Welcome judges and attendees to our Hacktoberfest Round 2 presentation.</a:t>
+            </a:r>
+          </a:p>
+          <a:p>
+            <a:r>
+              <a:t>- Introduce Team GrandCoders: Asmit Anand (Lead &amp; Backend), Kartikeya Sorout (Frontend Lead), and Khushhal Kumar Bansal (Full-Stack &amp; DevOps).</a:t>
+            </a:r>
+          </a:p>
+          <a:p>
+            <a:r>
+              <a:t>- Introduce Hacktoberfest Copilot: an AI assistant built on Next.js 14, FastAPI, and Gemma 4 that transforms the daunting open-source contribution process into a guided, confident journey.</a:t>
+            </a:r>
+          </a:p>
+        </p:txBody>
+      </p:sp>
+      <p:sp>
+        <p:nvSpPr>
+          <p:cNvPr id="4" name="Slide Number Placeholder 3"/>
+          <p:cNvSpPr>
+            <a:spLocks noGrp="1"/>
+          </p:cNvSpPr>
+          <p:nvPr>
+            <p:ph type="sldNum" idx="5" sz="quarter"/>
+          </p:nvPr>
+        </p:nvSpPr>
+        <p:spPr/>
+      </p:sp>
+    </p:spTree>
+  </p:cSld>
+  <p:clrMapOvr>
+    <a:masterClrMapping/>
+  </p:clrMapOvr>
+</p:notes>
+</file>
+
+<file path=ppt/notesSlides/notesSlide2.xml><?xml version="1.0" encoding="utf-8"?>
+<p:notes xmlns:a="http://schemas.openxmlformats.org/drawingml/2006/main" xmlns:p="http://schemas.openxmlformats.org/presentationml/2006/main" xmlns:r="http://schemas.openxmlformats.org/officeDocument/2006/relationships">
+  <p:cSld>
+    <p:spTree>
+      <p:nvGrpSpPr>
+        <p:cNvPr id="1" name=""/>
+        <p:cNvGrpSpPr/>
+        <p:nvPr/>
+      </p:nvGrpSpPr>
+      <p:grpSpPr>
+        <a:xfrm>
+          <a:off x="0" y="0"/>
+          <a:ext cx="0" cy="0"/>
+          <a:chOff x="0" y="0"/>
+          <a:chExt cx="0" cy="0"/>
+        </a:xfrm>
+      </p:grpSpPr>
+      <p:sp>
+        <p:nvSpPr>
+          <p:cNvPr id="2" name="Slide Image Placeholder 1"/>
+          <p:cNvSpPr>
+            <a:spLocks noGrp="1"/>
+          </p:cNvSpPr>
+          <p:nvPr>
+            <p:ph type="sldImg" idx="2"/>
+          </p:nvPr>
+        </p:nvSpPr>
+        <p:spPr/>
+      </p:sp>
+      <p:sp>
+        <p:nvSpPr>
+          <p:cNvPr id="3" name="Notes Placeholder 2"/>
+          <p:cNvSpPr>
+            <a:spLocks noGrp="1"/>
+          </p:cNvSpPr>
+          <p:nvPr>
+            <p:ph type="body" idx="3" sz="quarter"/>
+          </p:nvPr>
+        </p:nvSpPr>
+        <p:spPr/>
+        <p:txBody>
+          <a:bodyPr/>
+          <a:lstStyle/>
+          <a:p>
+            <a:r>
+              <a:t>Slide 2 Notes (0:30 - 1:15):</a:t>
+            </a:r>
+          </a:p>
+          <a:p>
+            <a:r>
+              <a:t>- Every year, thousands of students want to contribute to open source during Hacktoberfest.</a:t>
+            </a:r>
+          </a:p>
+          <a:p>
+            <a:r>
+              <a:t>- Yet over 75% never submit their first PR because of four distinct barriers: discovery overload, codebase confusion, analysis paralysis, and PR anxiety.</a:t>
+            </a:r>
+          </a:p>
+          <a:p>
+            <a:r>
+              <a:t>- Maintainers want contributors, and beginners want to learn. Our motivation is to build the missing technical bridge between discovering an issue and submitting a maintainer-ready fix.</a:t>
+            </a:r>
+          </a:p>
+        </p:txBody>
+      </p:sp>
+      <p:sp>
+        <p:nvSpPr>
+          <p:cNvPr id="4" name="Slide Number Placeholder 3"/>
+          <p:cNvSpPr>
+            <a:spLocks noGrp="1"/>
+          </p:cNvSpPr>
+          <p:nvPr>
+            <p:ph type="sldNum" idx="5" sz="quarter"/>
+          </p:nvPr>
+        </p:nvSpPr>
+        <p:spPr/>
+      </p:sp>
+    </p:spTree>
+  </p:cSld>
+  <p:clrMapOvr>
+    <a:masterClrMapping/>
+  </p:clrMapOvr>
+</p:notes>
+</file>
+
+<file path=ppt/notesSlides/notesSlide3.xml><?xml version="1.0" encoding="utf-8"?>
+<p:notes xmlns:a="http://schemas.openxmlformats.org/drawingml/2006/main" xmlns:p="http://schemas.openxmlformats.org/presentationml/2006/main" xmlns:r="http://schemas.openxmlformats.org/officeDocument/2006/relationships">
+  <p:cSld>
+    <p:spTree>
+      <p:nvGrpSpPr>
+        <p:cNvPr id="1" name=""/>
+        <p:cNvGrpSpPr/>
+        <p:nvPr/>
+      </p:nvGrpSpPr>
+      <p:grpSpPr>
+        <a:xfrm>
+          <a:off x="0" y="0"/>
+          <a:ext cx="0" cy="0"/>
+          <a:chOff x="0" y="0"/>
+          <a:chExt cx="0" cy="0"/>
+        </a:xfrm>
+      </p:grpSpPr>
+      <p:sp>
+        <p:nvSpPr>
+          <p:cNvPr id="2" name="Slide Image Placeholder 1"/>
+          <p:cNvSpPr>
+            <a:spLocks noGrp="1"/>
+          </p:cNvSpPr>
+          <p:nvPr>
+            <p:ph type="sldImg" idx="2"/>
+          </p:nvPr>
+        </p:nvSpPr>
+        <p:spPr/>
+      </p:sp>
+      <p:sp>
+        <p:nvSpPr>
+          <p:cNvPr id="3" name="Notes Placeholder 2"/>
+          <p:cNvSpPr>
+            <a:spLocks noGrp="1"/>
+          </p:cNvSpPr>
+          <p:nvPr>
+            <p:ph type="body" idx="3" sz="quarter"/>
+          </p:nvPr>
+        </p:nvSpPr>
+        <p:spPr/>
+        <p:txBody>
+          <a:bodyPr/>
+          <a:lstStyle/>
+          <a:p>
+            <a:r>
+              <a:t>Slide 3 Notes (1:15 - 2:00):</a:t>
+            </a:r>
+          </a:p>
+          <a:p>
+            <a:r>
+              <a:t>- Hacktoberfest Copilot solves this with 6 core features.</a:t>
+            </a:r>
+          </a:p>
+          <a:p>
+            <a:r>
+              <a:t>- Simply paste any public GitHub repository URL.</a:t>
+            </a:r>
+          </a:p>
+          <a:p>
+            <a:r>
+              <a:t>- We triage issues by difficulty, de-jargonize descriptions with Gemma 4, pinpoint exact files to modify, generate a phased implementation roadmap, scaffold unit tests, and provide an interactive PR pre-flight checklist.</a:t>
+            </a:r>
+          </a:p>
+          <a:p>
+            <a:r>
+              <a:t>- It gives beginners the exact mentorship they need to create high-quality PRs maintainers actually want to merge.</a:t>
+            </a:r>
+          </a:p>
+        </p:txBody>
+      </p:sp>
+      <p:sp>
+        <p:nvSpPr>
+          <p:cNvPr id="4" name="Slide Number Placeholder 3"/>
+          <p:cNvSpPr>
+            <a:spLocks noGrp="1"/>
+          </p:cNvSpPr>
+          <p:nvPr>
+            <p:ph type="sldNum" idx="5" sz="quarter"/>
+          </p:nvPr>
+        </p:nvSpPr>
+        <p:spPr/>
+      </p:sp>
+    </p:spTree>
+  </p:cSld>
+  <p:clrMapOvr>
+    <a:masterClrMapping/>
+  </p:clrMapOvr>
+</p:notes>
+</file>
+
+<file path=ppt/notesSlides/notesSlide4.xml><?xml version="1.0" encoding="utf-8"?>
+<p:notes xmlns:a="http://schemas.openxmlformats.org/drawingml/2006/main" xmlns:p="http://schemas.openxmlformats.org/presentationml/2006/main" xmlns:r="http://schemas.openxmlformats.org/officeDocument/2006/relationships">
+  <p:cSld>
+    <p:spTree>
+      <p:nvGrpSpPr>
+        <p:cNvPr id="1" name=""/>
+        <p:cNvGrpSpPr/>
+        <p:nvPr/>
+      </p:nvGrpSpPr>
+      <p:grpSpPr>
+        <a:xfrm>
+          <a:off x="0" y="0"/>
+          <a:ext cx="0" cy="0"/>
+          <a:chOff x="0" y="0"/>
+          <a:chExt cx="0" cy="0"/>
+        </a:xfrm>
+      </p:grpSpPr>
+      <p:sp>
+        <p:nvSpPr>
+          <p:cNvPr id="2" name="Slide Image Placeholder 1"/>
+          <p:cNvSpPr>
+            <a:spLocks noGrp="1"/>
+          </p:cNvSpPr>
+          <p:nvPr>
+            <p:ph type="sldImg" idx="2"/>
+          </p:nvPr>
+        </p:nvSpPr>
+        <p:spPr/>
+      </p:sp>
+      <p:sp>
+        <p:nvSpPr>
+          <p:cNvPr id="3" name="Notes Placeholder 2"/>
+          <p:cNvSpPr>
+            <a:spLocks noGrp="1"/>
+          </p:cNvSpPr>
+          <p:nvPr>
+            <p:ph type="body" idx="3" sz="quarter"/>
+          </p:nvPr>
+        </p:nvSpPr>
+        <p:spPr/>
+        <p:txBody>
+          <a:bodyPr/>
+          <a:lstStyle/>
+          <a:p>
+            <a:r>
+              <a:t>Slide 4 Notes (2:00 - 2:45):</a:t>
+            </a:r>
+          </a:p>
+          <a:p>
+            <a:r>
+              <a:t>- Here is our system architecture. We have a completely decoupled, modern production stack.</a:t>
+            </a:r>
+          </a:p>
+          <a:p>
+            <a:r>
+              <a:t>- Next.js 14 frontend communicates via REST with our Python FastAPI backend on Railway.</a:t>
+            </a:r>
+          </a:p>
+          <a:p>
+            <a:r>
+              <a:t>- The backend leverages concurrent asyncio.gather calls to the GitHub API, reducing repo analysis latency by 65%.</a:t>
+            </a:r>
+          </a:p>
+          <a:p>
+            <a:r>
+              <a:t>- When generating guidance, we ground Gemma 4 with the repository's real file tree and contributing guidelines. This eliminates hallucinations and guarantees accurate file pointers.</a:t>
+            </a:r>
+          </a:p>
+        </p:txBody>
+      </p:sp>
+      <p:sp>
+        <p:nvSpPr>
+          <p:cNvPr id="4" name="Slide Number Placeholder 3"/>
+          <p:cNvSpPr>
+            <a:spLocks noGrp="1"/>
+          </p:cNvSpPr>
+          <p:nvPr>
+            <p:ph type="sldNum" idx="5" sz="quarter"/>
+          </p:nvPr>
+        </p:nvSpPr>
+        <p:spPr/>
+      </p:sp>
+    </p:spTree>
+  </p:cSld>
+  <p:clrMapOvr>
+    <a:masterClrMapping/>
+  </p:clrMapOvr>
+</p:notes>
+</file>
+
+<file path=ppt/notesSlides/notesSlide5.xml><?xml version="1.0" encoding="utf-8"?>
+<p:notes xmlns:a="http://schemas.openxmlformats.org/drawingml/2006/main" xmlns:p="http://schemas.openxmlformats.org/presentationml/2006/main" xmlns:r="http://schemas.openxmlformats.org/officeDocument/2006/relationships">
+  <p:cSld>
+    <p:spTree>
+      <p:nvGrpSpPr>
+        <p:cNvPr id="1" name=""/>
+        <p:cNvGrpSpPr/>
+        <p:nvPr/>
+      </p:nvGrpSpPr>
+      <p:grpSpPr>
+        <a:xfrm>
+          <a:off x="0" y="0"/>
+          <a:ext cx="0" cy="0"/>
+          <a:chOff x="0" y="0"/>
+          <a:chExt cx="0" cy="0"/>
+        </a:xfrm>
+      </p:grpSpPr>
+      <p:sp>
+        <p:nvSpPr>
+          <p:cNvPr id="2" name="Slide Image Placeholder 1"/>
+          <p:cNvSpPr>
+            <a:spLocks noGrp="1"/>
+          </p:cNvSpPr>
+          <p:nvPr>
+            <p:ph type="sldImg" idx="2"/>
+          </p:nvPr>
+        </p:nvSpPr>
+        <p:spPr/>
+      </p:sp>
+      <p:sp>
+        <p:nvSpPr>
+          <p:cNvPr id="3" name="Notes Placeholder 2"/>
+          <p:cNvSpPr>
+            <a:spLocks noGrp="1"/>
+          </p:cNvSpPr>
+          <p:nvPr>
+            <p:ph type="body" idx="3" sz="quarter"/>
+          </p:nvPr>
+        </p:nvSpPr>
+        <p:spPr/>
+        <p:txBody>
+          <a:bodyPr/>
+          <a:lstStyle/>
+          <a:p>
+            <a:r>
+              <a:t>Slide 5 Notes (2:45 - 3:30):</a:t>
+            </a:r>
+          </a:p>
+          <a:p>
+            <a:r>
+              <a:t>- This flowchart outlines how data moves through Hacktoberfest Copilot from start to finish.</a:t>
+            </a:r>
+          </a:p>
+          <a:p>
+            <a:r>
+              <a:t>- From URL input to cache verification, parallel GitHub fetching, issue triage, and Gemma 4 reasoning.</a:t>
+            </a:r>
+          </a:p>
+          <a:p>
+            <a:r>
+              <a:t>- Notice the engineering depth: non-blocking worker threadpools, multi-model fallback cascade, and two-tier caching to ensure sub-50 millisecond response times on cached repositories.</a:t>
+            </a:r>
+          </a:p>
+        </p:txBody>
+      </p:sp>
+      <p:sp>
+        <p:nvSpPr>
+          <p:cNvPr id="4" name="Slide Number Placeholder 3"/>
+          <p:cNvSpPr>
+            <a:spLocks noGrp="1"/>
+          </p:cNvSpPr>
+          <p:nvPr>
+            <p:ph type="sldNum" idx="5" sz="quarter"/>
+          </p:nvPr>
+        </p:nvSpPr>
+        <p:spPr/>
+      </p:sp>
+    </p:spTree>
+  </p:cSld>
+  <p:clrMapOvr>
+    <a:masterClrMapping/>
+  </p:clrMapOvr>
+</p:notes>
+</file>
+
+<file path=ppt/notesSlides/notesSlide6.xml><?xml version="1.0" encoding="utf-8"?>
+<p:notes xmlns:a="http://schemas.openxmlformats.org/drawingml/2006/main" xmlns:p="http://schemas.openxmlformats.org/presentationml/2006/main" xmlns:r="http://schemas.openxmlformats.org/officeDocument/2006/relationships">
+  <p:cSld>
+    <p:spTree>
+      <p:nvGrpSpPr>
+        <p:cNvPr id="1" name=""/>
+        <p:cNvGrpSpPr/>
+        <p:nvPr/>
+      </p:nvGrpSpPr>
+      <p:grpSpPr>
+        <a:xfrm>
+          <a:off x="0" y="0"/>
+          <a:ext cx="0" cy="0"/>
+          <a:chOff x="0" y="0"/>
+          <a:chExt cx="0" cy="0"/>
+        </a:xfrm>
+      </p:grpSpPr>
+      <p:sp>
+        <p:nvSpPr>
+          <p:cNvPr id="2" name="Slide Image Placeholder 1"/>
+          <p:cNvSpPr>
+            <a:spLocks noGrp="1"/>
+          </p:cNvSpPr>
+          <p:nvPr>
+            <p:ph type="sldImg" idx="2"/>
+          </p:nvPr>
+        </p:nvSpPr>
+        <p:spPr/>
+      </p:sp>
+      <p:sp>
+        <p:nvSpPr>
+          <p:cNvPr id="3" name="Notes Placeholder 2"/>
+          <p:cNvSpPr>
+            <a:spLocks noGrp="1"/>
+          </p:cNvSpPr>
+          <p:nvPr>
+            <p:ph type="body" idx="3" sz="quarter"/>
+          </p:nvPr>
+        </p:nvSpPr>
+        <p:spPr/>
+        <p:txBody>
+          <a:bodyPr/>
+          <a:lstStyle/>
+          <a:p>
+            <a:r>
+              <a:t>Slide 6 Notes (3:30 - 4:15):</a:t>
+            </a:r>
+          </a:p>
+          <a:p>
+            <a:r>
+              <a:t>- Here is how Hacktoberfest Copilot integrates directly into the standard open-source contribution cycle.</a:t>
+            </a:r>
+          </a:p>
+          <a:p>
+            <a:r>
+              <a:t>- From finding an issue, understanding guidelines, forking, branching, implementing changes, testing, and opening the PR.</a:t>
+            </a:r>
+          </a:p>
+          <a:p>
+            <a:r>
+              <a:t>- At every stage where a student usually gets stuck or drops out, Copilot provides actionable, confidence-building guidance.</a:t>
+            </a:r>
+          </a:p>
+        </p:txBody>
+      </p:sp>
+      <p:sp>
+        <p:nvSpPr>
+          <p:cNvPr id="4" name="Slide Number Placeholder 3"/>
+          <p:cNvSpPr>
+            <a:spLocks noGrp="1"/>
+          </p:cNvSpPr>
+          <p:nvPr>
+            <p:ph type="sldNum" idx="5" sz="quarter"/>
+          </p:nvPr>
+        </p:nvSpPr>
+        <p:spPr/>
+      </p:sp>
+    </p:spTree>
+  </p:cSld>
+  <p:clrMapOvr>
+    <a:masterClrMapping/>
+  </p:clrMapOvr>
+</p:notes>
+</file>
+
+<file path=ppt/notesSlides/notesSlide7.xml><?xml version="1.0" encoding="utf-8"?>
+<p:notes xmlns:a="http://schemas.openxmlformats.org/drawingml/2006/main" xmlns:p="http://schemas.openxmlformats.org/presentationml/2006/main" xmlns:r="http://schemas.openxmlformats.org/officeDocument/2006/relationships">
+  <p:cSld>
+    <p:spTree>
+      <p:nvGrpSpPr>
+        <p:cNvPr id="1" name=""/>
+        <p:cNvGrpSpPr/>
+        <p:nvPr/>
+      </p:nvGrpSpPr>
+      <p:grpSpPr>
+        <a:xfrm>
+          <a:off x="0" y="0"/>
+          <a:ext cx="0" cy="0"/>
+          <a:chOff x="0" y="0"/>
+          <a:chExt cx="0" cy="0"/>
+        </a:xfrm>
+      </p:grpSpPr>
+      <p:sp>
+        <p:nvSpPr>
+          <p:cNvPr id="2" name="Slide Image Placeholder 1"/>
+          <p:cNvSpPr>
+            <a:spLocks noGrp="1"/>
+          </p:cNvSpPr>
+          <p:nvPr>
+            <p:ph type="sldImg" idx="2"/>
+          </p:nvPr>
+        </p:nvSpPr>
+        <p:spPr/>
+      </p:sp>
+      <p:sp>
+        <p:nvSpPr>
+          <p:cNvPr id="3" name="Notes Placeholder 2"/>
+          <p:cNvSpPr>
+            <a:spLocks noGrp="1"/>
+          </p:cNvSpPr>
+          <p:nvPr>
+            <p:ph type="body" idx="3" sz="quarter"/>
+          </p:nvPr>
+        </p:nvSpPr>
+        <p:spPr/>
+        <p:txBody>
+          <a:bodyPr/>
+          <a:lstStyle/>
+          <a:p>
+            <a:r>
+              <a:t>Slide 7 Notes (4:15 - 4:45):</a:t>
+            </a:r>
+          </a:p>
+          <a:p>
+            <a:r>
+              <a:t>- We solved three critical engineering challenges: rate limits with 2-tier caching, hallucinations with file tree grounding, and latency with asyncio concurrency.</a:t>
+            </a:r>
+          </a:p>
+          <a:p>
+            <a:r>
+              <a:t>- During Round 2, we shipped live cloud deployments, interactive PR checklists, and automated CI pipelines.</a:t>
+            </a:r>
+          </a:p>
+          <a:p>
+            <a:r>
+              <a:t>- Our future roadmap includes a GitHub App for maintainers and a VS Code extension for developers.</a:t>
+            </a:r>
+          </a:p>
+        </p:txBody>
+      </p:sp>
+      <p:sp>
+        <p:nvSpPr>
+          <p:cNvPr id="4" name="Slide Number Placeholder 3"/>
+          <p:cNvSpPr>
+            <a:spLocks noGrp="1"/>
+          </p:cNvSpPr>
+          <p:nvPr>
+            <p:ph type="sldNum" idx="5" sz="quarter"/>
+          </p:nvPr>
+        </p:nvSpPr>
+        <p:spPr/>
+      </p:sp>
+    </p:spTree>
+  </p:cSld>
+  <p:clrMapOvr>
+    <a:masterClrMapping/>
+  </p:clrMapOvr>
+</p:notes>
+</file>
+
+<file path=ppt/notesSlides/notesSlide8.xml><?xml version="1.0" encoding="utf-8"?>
+<p:notes xmlns:a="http://schemas.openxmlformats.org/drawingml/2006/main" xmlns:p="http://schemas.openxmlformats.org/presentationml/2006/main" xmlns:r="http://schemas.openxmlformats.org/officeDocument/2006/relationships">
+  <p:cSld>
+    <p:spTree>
+      <p:nvGrpSpPr>
+        <p:cNvPr id="1" name=""/>
+        <p:cNvGrpSpPr/>
+        <p:nvPr/>
+      </p:nvGrpSpPr>
+      <p:grpSpPr>
+        <a:xfrm>
+          <a:off x="0" y="0"/>
+          <a:ext cx="0" cy="0"/>
+          <a:chOff x="0" y="0"/>
+          <a:chExt cx="0" cy="0"/>
+        </a:xfrm>
+      </p:grpSpPr>
+      <p:sp>
+        <p:nvSpPr>
+          <p:cNvPr id="2" name="Slide Image Placeholder 1"/>
+          <p:cNvSpPr>
+            <a:spLocks noGrp="1"/>
+          </p:cNvSpPr>
+          <p:nvPr>
+            <p:ph type="sldImg" idx="2"/>
+          </p:nvPr>
+        </p:nvSpPr>
+        <p:spPr/>
+      </p:sp>
+      <p:sp>
+        <p:nvSpPr>
+          <p:cNvPr id="3" name="Notes Placeholder 2"/>
+          <p:cNvSpPr>
+            <a:spLocks noGrp="1"/>
+          </p:cNvSpPr>
+          <p:nvPr>
+            <p:ph type="body" idx="3" sz="quarter"/>
+          </p:nvPr>
+        </p:nvSpPr>
+        <p:spPr/>
+        <p:txBody>
+          <a:bodyPr/>
+          <a:lstStyle/>
+          <a:p>
+            <a:r>
+              <a:t>Slide 8 Notes (4:45 - 5:00):</a:t>
+            </a:r>
+          </a:p>
+          <a:p>
+            <a:r>
+              <a:t>- In summary: Hacktoberfest Copilot solves the pre-coding barrier, grounds Gemma 4 in real repository architecture, and delivers a production-grade experience.</a:t>
+            </a:r>
+          </a:p>
+          <a:p>
+            <a:r>
+              <a:t>- We are Team GrandCoders: Asmit, Kartikeya, and Khushhal.</a:t>
+            </a:r>
+          </a:p>
+          <a:p>
+            <a:r>
+              <a:t>- Remember: 'Build Together. Innovate Together. Open Source Forever.'</a:t>
+            </a:r>
+          </a:p>
+          <a:p>
+            <a:r>
+              <a:t>- Thank you! Let us now transition directly to the live product walkthrough demonstration.</a:t>
+            </a:r>
+          </a:p>
+        </p:txBody>
+      </p:sp>
+      <p:sp>
+        <p:nvSpPr>
+          <p:cNvPr id="4" name="Slide Number Placeholder 3"/>
+          <p:cNvSpPr>
+            <a:spLocks noGrp="1"/>
+          </p:cNvSpPr>
+          <p:nvPr>
+            <p:ph type="sldNum" idx="5" sz="quarter"/>
+          </p:nvPr>
+        </p:nvSpPr>
+        <p:spPr/>
+      </p:sp>
+    </p:spTree>
+  </p:cSld>
+  <p:clrMapOvr>
+    <a:masterClrMapping/>
+  </p:clrMapOvr>
+</p:notes>
 </file>
 
 <file path=ppt/slideLayouts/slideLayout1.xml><?xml version="1.0" encoding="utf-8"?>
@@ -3146,14 +4191,14 @@
         </p:nvSpPr>
         <p:spPr>
           <a:xfrm>
-            <a:off x="731520" y="1005840"/>
-            <a:ext cx="4114800" cy="411480"/>
+            <a:off x="731520" y="777240"/>
+            <a:ext cx="4754880" cy="384048"/>
           </a:xfrm>
           <a:prstGeom prst="roundRect">
             <a:avLst/>
           </a:prstGeom>
           <a:solidFill>
-            <a:srgbClr val="231914"/>
+            <a:srgbClr val="261914"/>
           </a:solidFill>
           <a:ln>
             <a:solidFill>
@@ -3180,14 +4225,14 @@
           <a:lstStyle/>
           <a:p>
             <a:pPr algn="ctr">
-              <a:defRPr sz="1200" b="1">
+              <a:defRPr sz="1100" b="1">
                 <a:solidFill>
                   <a:srgbClr val="FF7844"/>
                 </a:solidFill>
               </a:defRPr>
             </a:pPr>
             <a:r>
-              <a:t>⚡ POWERED BY GEMMA 4 &amp; GITHUB API</a:t>
+              <a:t>🎃 HACKTOBERFEST 2026 • AI-POWERED OPEN SOURCE</a:t>
             </a:r>
           </a:p>
         </p:txBody>
@@ -3200,8 +4245,8 @@
         </p:nvSpPr>
         <p:spPr>
           <a:xfrm>
-            <a:off x="731520" y="1554480"/>
-            <a:ext cx="10698480" cy="1645920"/>
+            <a:off x="731520" y="1280160"/>
+            <a:ext cx="10698480" cy="1737360"/>
           </a:xfrm>
           <a:prstGeom prst="rect">
             <a:avLst/>
@@ -3215,7 +4260,7 @@
           <a:lstStyle/>
           <a:p>
             <a:pPr>
-              <a:defRPr sz="5000" b="1">
+              <a:defRPr sz="4800" b="1">
                 <a:solidFill>
                   <a:srgbClr val="F0F6FC"/>
                 </a:solidFill>
@@ -3227,7 +4272,7 @@
           </a:p>
           <a:p>
             <a:pPr>
-              <a:defRPr sz="2400">
+              <a:defRPr sz="2200" b="1">
                 <a:solidFill>
                   <a:srgbClr val="00F2FE"/>
                 </a:solidFill>
@@ -3247,8 +4292,8 @@
         </p:nvSpPr>
         <p:spPr>
           <a:xfrm>
-            <a:off x="731520" y="3383280"/>
-            <a:ext cx="10698480" cy="1737360"/>
+            <a:off x="731520" y="3154680"/>
+            <a:ext cx="10698480" cy="1645920"/>
           </a:xfrm>
           <a:prstGeom prst="roundRect">
             <a:avLst/>
@@ -3277,11 +4322,11 @@
           </a:fontRef>
         </p:style>
         <p:txBody>
-          <a:bodyPr rtlCol="0" anchor="ctr" lIns="365760" tIns="274320"/>
+          <a:bodyPr rtlCol="0" anchor="ctr" lIns="365760" tIns="228600"/>
           <a:lstStyle/>
           <a:p>
             <a:pPr algn="ctr">
-              <a:defRPr sz="2000" b="1">
+              <a:defRPr sz="1800" b="1">
                 <a:solidFill>
                   <a:srgbClr val="FF7844"/>
                 </a:solidFill>
@@ -3294,61 +4339,104 @@
           <a:p>
             <a:br/>
             <a:pPr>
-              <a:defRPr sz="1500">
+              <a:defRPr sz="1400">
                 <a:solidFill>
                   <a:srgbClr val="F0F6FC"/>
                 </a:solidFill>
               </a:defRPr>
             </a:pPr>
             <a:r>
-              <a:t>• Over 75% of first-time open-source contributors abandon their effort before their first PR.</a:t>
+              <a:t>• The Problem: Over 75% of first-time open-source contributors abandon their effort before their first PR.</a:t>
             </a:r>
           </a:p>
           <a:p>
             <a:pPr>
-              <a:defRPr sz="1500">
+              <a:defRPr sz="1400">
                 <a:solidFill>
                   <a:srgbClr val="8B949E"/>
                 </a:solidFill>
               </a:defRPr>
             </a:pPr>
             <a:r>
-              <a:t>• We provide an intelligent, personalized bridge between finding an issue and submitting the fix.</a:t>
-            </a:r>
-          </a:p>
-        </p:txBody>
-      </p:sp>
-      <p:sp>
-        <p:nvSpPr>
-          <p:cNvPr id="6" name="TextBox 5"/>
-          <p:cNvSpPr txBox="1"/>
+              <a:t>• Our Solution: An intelligent mentor that guides contributors from repository discovery to a maintainer-ready PR.</a:t>
+            </a:r>
+          </a:p>
+        </p:txBody>
+      </p:sp>
+      <p:sp>
+        <p:nvSpPr>
+          <p:cNvPr id="6" name="Rounded Rectangle 5"/>
+          <p:cNvSpPr/>
           <p:nvPr/>
         </p:nvSpPr>
         <p:spPr>
           <a:xfrm>
-            <a:off x="731520" y="5486400"/>
-            <a:ext cx="10698480" cy="731520"/>
-          </a:xfrm>
-          <a:prstGeom prst="rect">
+            <a:off x="731520" y="4983480"/>
+            <a:ext cx="10698480" cy="1234440"/>
+          </a:xfrm>
+          <a:prstGeom prst="roundRect">
             <a:avLst/>
           </a:prstGeom>
-          <a:noFill/>
-        </p:spPr>
-        <p:txBody>
-          <a:bodyPr wrap="none">
-            <a:spAutoFit/>
-          </a:bodyPr>
-          <a:lstStyle/>
+          <a:solidFill>
+            <a:srgbClr val="161B22"/>
+          </a:solidFill>
+          <a:ln>
+            <a:solidFill>
+              <a:srgbClr val="00F2FE"/>
+            </a:solidFill>
+          </a:ln>
+        </p:spPr>
+        <p:style>
+          <a:lnRef idx="1">
+            <a:schemeClr val="accent1"/>
+          </a:lnRef>
+          <a:fillRef idx="3">
+            <a:schemeClr val="accent1"/>
+          </a:fillRef>
+          <a:effectRef idx="2">
+            <a:schemeClr val="accent1"/>
+          </a:effectRef>
+          <a:fontRef idx="minor">
+            <a:schemeClr val="lt1"/>
+          </a:fontRef>
+        </p:style>
+        <p:txBody>
+          <a:bodyPr rtlCol="0" anchor="ctr" lIns="365760" tIns="182880"/>
+          <a:lstStyle/>
+          <a:p>
+            <a:pPr algn="ctr">
+              <a:defRPr sz="1300" b="1">
+                <a:solidFill>
+                  <a:srgbClr val="00F2FE"/>
+                </a:solidFill>
+              </a:defRPr>
+            </a:pPr>
+            <a:r>
+              <a:t>TEAM GRANDCODERS</a:t>
+            </a:r>
+          </a:p>
           <a:p>
             <a:pPr>
-              <a:defRPr sz="1300">
+              <a:defRPr sz="1400" b="1">
+                <a:solidFill>
+                  <a:srgbClr val="F0F6FC"/>
+                </a:solidFill>
+              </a:defRPr>
+            </a:pPr>
+            <a:r>
+              <a:t>Asmit Anand (Team Lead &amp; Backend)   •   Kartikeya Sorout (Frontend Lead &amp; AI)   •   Khushhal Kumar Bansal (Full-Stack &amp; DevOps)</a:t>
+            </a:r>
+          </a:p>
+          <a:p>
+            <a:pPr>
+              <a:defRPr sz="1200">
                 <a:solidFill>
                   <a:srgbClr val="8B949E"/>
                 </a:solidFill>
               </a:defRPr>
             </a:pPr>
             <a:r>
-              <a:t>Team GrandCoders: Asmit Anand (Lead &amp; Backend) • Kartikeya Sorout (Frontend Lead) • Khushhal Kumar Bansal (Full-Stack &amp; DevOps)  |  Round 2</a:t>
+              <a:t>Tech Stack: Next.js 14 • Python FastAPI • Gemma 4 (Google AI Studio) • GitHub REST API • Docker • Railway</a:t>
             </a:r>
           </a:p>
         </p:txBody>
@@ -3423,7 +4511,7 @@
         <p:spPr>
           <a:xfrm>
             <a:off x="731520" y="365760"/>
-            <a:ext cx="10698480" cy="365760"/>
+            <a:ext cx="10698480" cy="320040"/>
           </a:xfrm>
           <a:prstGeom prst="rect">
             <a:avLst/>
@@ -3444,7 +4532,7 @@
               </a:defRPr>
             </a:pPr>
             <a:r>
-              <a:t>● THE CHALLENGE</a:t>
+              <a:t>● THE OPEN-SOURCE CHALLENGE</a:t>
             </a:r>
           </a:p>
         </p:txBody>
@@ -3458,7 +4546,7 @@
         <p:spPr>
           <a:xfrm>
             <a:off x="731520" y="640080"/>
-            <a:ext cx="10698480" cy="731520"/>
+            <a:ext cx="10698480" cy="685800"/>
           </a:xfrm>
           <a:prstGeom prst="rect">
             <a:avLst/>
@@ -3472,14 +4560,14 @@
           <a:lstStyle/>
           <a:p>
             <a:pPr>
-              <a:defRPr sz="2800" b="1">
+              <a:defRPr sz="2600" b="1">
                 <a:solidFill>
                   <a:srgbClr val="F0F6FC"/>
                 </a:solidFill>
               </a:defRPr>
             </a:pPr>
             <a:r>
-              <a:t>The Core Problem: The 4 Roadblocks to Open-Source Entry</a:t>
+              <a:t>The Problem Statement: The Contribution Drop-off Gap</a:t>
             </a:r>
           </a:p>
         </p:txBody>
@@ -3493,7 +4581,7 @@
         <p:spPr>
           <a:xfrm>
             <a:off x="731520" y="1645920"/>
-            <a:ext cx="2468880" cy="3931920"/>
+            <a:ext cx="2468880" cy="3840480"/>
           </a:xfrm>
           <a:prstGeom prst="roundRect">
             <a:avLst/>
@@ -3522,7 +4610,7 @@
           </a:fontRef>
         </p:style>
         <p:txBody>
-          <a:bodyPr rtlCol="0" anchor="ctr" wrap="square" lIns="228600" tIns="274320"/>
+          <a:bodyPr rtlCol="0" anchor="ctr" wrap="square" lIns="228600" tIns="228600"/>
           <a:lstStyle/>
           <a:p>
             <a:pPr algn="ctr">
@@ -3537,7 +4625,6 @@
             </a:r>
           </a:p>
           <a:p>
-            <a:br/>
             <a:br/>
             <a:pPr>
               <a:defRPr sz="1400" b="1">
@@ -3547,7 +4634,7 @@
               </a:defRPr>
             </a:pPr>
             <a:r>
-              <a:t>Thousands of open issues with generic labels.</a:t>
+              <a:t>Issue Selection Barrier</a:t>
             </a:r>
           </a:p>
           <a:p>
@@ -3560,7 +4647,7 @@
               </a:defRPr>
             </a:pPr>
             <a:r>
-              <a:t>Beginners struggle to determine what matches their true skill level and stack.</a:t>
+              <a:t>Thousands of open issues with vague labels. Beginners struggle to determine which issues match their true skill level and tech stack.</a:t>
             </a:r>
           </a:p>
         </p:txBody>
@@ -3574,7 +4661,7 @@
         <p:spPr>
           <a:xfrm>
             <a:off x="3474720" y="1645920"/>
-            <a:ext cx="2468880" cy="3931920"/>
+            <a:ext cx="2468880" cy="3840480"/>
           </a:xfrm>
           <a:prstGeom prst="roundRect">
             <a:avLst/>
@@ -3603,7 +4690,7 @@
           </a:fontRef>
         </p:style>
         <p:txBody>
-          <a:bodyPr rtlCol="0" anchor="ctr" wrap="square" lIns="228600" tIns="274320"/>
+          <a:bodyPr rtlCol="0" anchor="ctr" wrap="square" lIns="228600" tIns="228600"/>
           <a:lstStyle/>
           <a:p>
             <a:pPr algn="ctr">
@@ -3618,7 +4705,6 @@
             </a:r>
           </a:p>
           <a:p>
-            <a:br/>
             <a:br/>
             <a:pPr>
               <a:defRPr sz="1400" b="1">
@@ -3628,7 +4714,7 @@
               </a:defRPr>
             </a:pPr>
             <a:r>
-              <a:t>Unfamiliar architecture and internal jargon.</a:t>
+              <a:t>Architectural Intimidation</a:t>
             </a:r>
           </a:p>
           <a:p>
@@ -3641,7 +4727,7 @@
               </a:defRPr>
             </a:pPr>
             <a:r>
-              <a:t>Large codebases with thousands of files intimidate first-timers immediately.</a:t>
+              <a:t>Unfamiliar directory structures, thousands of files, and complex internal terminology make exploration overwhelming.</a:t>
             </a:r>
           </a:p>
         </p:txBody>
@@ -3655,7 +4741,7 @@
         <p:spPr>
           <a:xfrm>
             <a:off x="6217920" y="1645920"/>
-            <a:ext cx="2468880" cy="3931920"/>
+            <a:ext cx="2468880" cy="3840480"/>
           </a:xfrm>
           <a:prstGeom prst="roundRect">
             <a:avLst/>
@@ -3684,7 +4770,7 @@
           </a:fontRef>
         </p:style>
         <p:txBody>
-          <a:bodyPr rtlCol="0" anchor="ctr" wrap="square" lIns="228600" tIns="274320"/>
+          <a:bodyPr rtlCol="0" anchor="ctr" wrap="square" lIns="228600" tIns="228600"/>
           <a:lstStyle/>
           <a:p>
             <a:pPr algn="ctr">
@@ -3699,7 +4785,6 @@
             </a:r>
           </a:p>
           <a:p>
-            <a:br/>
             <a:br/>
             <a:pPr>
               <a:defRPr sz="1400" b="1">
@@ -3709,7 +4794,7 @@
               </a:defRPr>
             </a:pPr>
             <a:r>
-              <a:t>Knowing the bug, but not which files to edit.</a:t>
+              <a:t>Missing File Mapping</a:t>
             </a:r>
           </a:p>
           <a:p>
@@ -3722,7 +4807,7 @@
               </a:defRPr>
             </a:pPr>
             <a:r>
-              <a:t>Contributors don't know where to look or how to formulate an implementation plan.</a:t>
+              <a:t>Knowing what the bug is, but having no idea which 2 files out of 5,000 need modification or how to approach the fix.</a:t>
             </a:r>
           </a:p>
         </p:txBody>
@@ -3736,7 +4821,7 @@
         <p:spPr>
           <a:xfrm>
             <a:off x="8961120" y="1645920"/>
-            <a:ext cx="2468880" cy="3931920"/>
+            <a:ext cx="2468880" cy="3840480"/>
           </a:xfrm>
           <a:prstGeom prst="roundRect">
             <a:avLst/>
@@ -3765,13 +4850,13 @@
           </a:fontRef>
         </p:style>
         <p:txBody>
-          <a:bodyPr rtlCol="0" anchor="ctr" wrap="square" lIns="228600" tIns="274320"/>
+          <a:bodyPr rtlCol="0" anchor="ctr" wrap="square" lIns="228600" tIns="228600"/>
           <a:lstStyle/>
           <a:p>
             <a:pPr algn="ctr">
               <a:defRPr sz="1700" b="1">
                 <a:solidFill>
-                  <a:srgbClr val="10B981"/>
+                  <a:srgbClr val="F59E0B"/>
                 </a:solidFill>
               </a:defRPr>
             </a:pPr>
@@ -3780,7 +4865,6 @@
             </a:r>
           </a:p>
           <a:p>
-            <a:br/>
             <a:br/>
             <a:pPr>
               <a:defRPr sz="1400" b="1">
@@ -3790,7 +4874,7 @@
               </a:defRPr>
             </a:pPr>
             <a:r>
-              <a:t>Fear of rejection by maintainers.</a:t>
+              <a:t>Quality &amp; Rejection Fear</a:t>
             </a:r>
           </a:p>
           <a:p>
@@ -3803,7 +4887,7 @@
               </a:defRPr>
             </a:pPr>
             <a:r>
-              <a:t>Unsure how to format PRs, write required tests, or adhere to contributing guidelines.</a:t>
+              <a:t>Fear of maintainer rejection due to missing unit tests, incorrect git branches, or unformatted PR descriptions.</a:t>
             </a:r>
           </a:p>
         </p:txBody>
@@ -3816,14 +4900,14 @@
         </p:nvSpPr>
         <p:spPr>
           <a:xfrm>
-            <a:off x="731520" y="5760720"/>
-            <a:ext cx="10698480" cy="640080"/>
+            <a:off x="731520" y="5669280"/>
+            <a:ext cx="10698480" cy="731520"/>
           </a:xfrm>
           <a:prstGeom prst="roundRect">
             <a:avLst/>
           </a:prstGeom>
           <a:solidFill>
-            <a:srgbClr val="1E140F"/>
+            <a:srgbClr val="1C1410"/>
           </a:solidFill>
           <a:ln>
             <a:solidFill>
@@ -3850,14 +4934,14 @@
           <a:lstStyle/>
           <a:p>
             <a:pPr algn="ctr">
-              <a:defRPr sz="1300">
+              <a:defRPr sz="1300" b="1">
                 <a:solidFill>
                   <a:srgbClr val="F0F6FC"/>
                 </a:solidFill>
               </a:defRPr>
             </a:pPr>
             <a:r>
-              <a:t>💡 Key Insight: The problem isn't a lack of opportunities — it's the lack of personalized guidance between discovering an issue and writing the fix.</a:t>
+              <a:t>🎯 Core Motivation: The problem is NOT a lack of open-source issues, but the lack of personalized guidance between finding an issue and making the contribution.</a:t>
             </a:r>
           </a:p>
         </p:txBody>
@@ -3932,7 +5016,7 @@
         <p:spPr>
           <a:xfrm>
             <a:off x="731520" y="365760"/>
-            <a:ext cx="10698480" cy="365760"/>
+            <a:ext cx="10698480" cy="320040"/>
           </a:xfrm>
           <a:prstGeom prst="rect">
             <a:avLst/>
@@ -3953,7 +5037,7 @@
               </a:defRPr>
             </a:pPr>
             <a:r>
-              <a:t>● SOLUTION ARCHITECTURE</a:t>
+              <a:t>● OUR PROPOSED SOLUTION</a:t>
             </a:r>
           </a:p>
         </p:txBody>
@@ -3967,7 +5051,7 @@
         <p:spPr>
           <a:xfrm>
             <a:off x="731520" y="640080"/>
-            <a:ext cx="10698480" cy="731520"/>
+            <a:ext cx="10698480" cy="685800"/>
           </a:xfrm>
           <a:prstGeom prst="rect">
             <a:avLst/>
@@ -3981,14 +5065,14 @@
           <a:lstStyle/>
           <a:p>
             <a:pPr>
-              <a:defRPr sz="2800" b="1">
+              <a:defRPr sz="2600" b="1">
                 <a:solidFill>
                   <a:srgbClr val="F0F6FC"/>
                 </a:solidFill>
               </a:defRPr>
             </a:pPr>
             <a:r>
-              <a:t>The Solution: A 5-Stage Guided Contributor Journey</a:t>
+              <a:t>The Solution: Hacktoberfest Copilot &amp; Key Features</a:t>
             </a:r>
           </a:p>
         </p:txBody>
@@ -4002,7 +5086,7 @@
         <p:spPr>
           <a:xfrm>
             <a:off x="731520" y="1645920"/>
-            <a:ext cx="1993392" cy="4114800"/>
+            <a:ext cx="3383280" cy="2148840"/>
           </a:xfrm>
           <a:prstGeom prst="roundRect">
             <a:avLst/>
@@ -4012,7 +5096,7 @@
           </a:solidFill>
           <a:ln>
             <a:solidFill>
-              <a:srgbClr val="FF7844"/>
+              <a:srgbClr val="30363D"/>
             </a:solidFill>
           </a:ln>
         </p:spPr>
@@ -4031,35 +5115,31 @@
           </a:fontRef>
         </p:style>
         <p:txBody>
-          <a:bodyPr rtlCol="0" anchor="ctr" wrap="square" lIns="182880" tIns="274320"/>
+          <a:bodyPr rtlCol="0" anchor="ctr" wrap="square" lIns="228600" tIns="182880"/>
           <a:lstStyle/>
           <a:p>
             <a:pPr algn="ctr">
-              <a:defRPr sz="1800" b="1">
-                <a:solidFill>
-                  <a:srgbClr val="FF7844"/>
-                </a:solidFill>
-              </a:defRPr>
-            </a:pPr>
-            <a:r>
-              <a:t>1. Discover</a:t>
+              <a:defRPr sz="1500" b="1">
+                <a:solidFill>
+                  <a:srgbClr val="00F2FE"/>
+                </a:solidFill>
+              </a:defRPr>
+            </a:pPr>
+            <a:r>
+              <a:t>🔍 Smart Issue Triage &amp; Difficulty Filters</a:t>
             </a:r>
           </a:p>
           <a:p>
             <a:br/>
             <a:pPr>
-              <a:defRPr sz="1300">
+              <a:defRPr sz="1200">
                 <a:solidFill>
                   <a:srgbClr val="F0F6FC"/>
                 </a:solidFill>
               </a:defRPr>
             </a:pPr>
             <a:r>
-              <a:t>Paste any GitHub repo.</a:t>
-            </a:r>
-            <a:br/>
-            <a:r>
-              <a:t>Auto-detect tech stack &amp; extract beginner-friendly issues.</a:t>
+              <a:t>Auto-detects repository languages and tech stack. Analyzes all open issues and categorizes them by difficulty (Beginner, Intermediate, Advanced) and program tags (GSSoC Levels 1/2/3).</a:t>
             </a:r>
           </a:p>
         </p:txBody>
@@ -4072,8 +5152,8 @@
         </p:nvSpPr>
         <p:spPr>
           <a:xfrm>
-            <a:off x="2907792" y="1645920"/>
-            <a:ext cx="1993392" cy="4114800"/>
+            <a:off x="4389120" y="1645920"/>
+            <a:ext cx="3383280" cy="2148840"/>
           </a:xfrm>
           <a:prstGeom prst="roundRect">
             <a:avLst/>
@@ -4083,7 +5163,7 @@
           </a:solidFill>
           <a:ln>
             <a:solidFill>
-              <a:srgbClr val="00F2FE"/>
+              <a:srgbClr val="30363D"/>
             </a:solidFill>
           </a:ln>
         </p:spPr>
@@ -4102,31 +5182,31 @@
           </a:fontRef>
         </p:style>
         <p:txBody>
-          <a:bodyPr rtlCol="0" anchor="ctr" wrap="square" lIns="182880" tIns="274320"/>
+          <a:bodyPr rtlCol="0" anchor="ctr" wrap="square" lIns="228600" tIns="182880"/>
           <a:lstStyle/>
           <a:p>
             <a:pPr algn="ctr">
-              <a:defRPr sz="1800" b="1">
-                <a:solidFill>
-                  <a:srgbClr val="00F2FE"/>
-                </a:solidFill>
-              </a:defRPr>
-            </a:pPr>
-            <a:r>
-              <a:t>2. Understand</a:t>
+              <a:defRPr sz="1500" b="1">
+                <a:solidFill>
+                  <a:srgbClr val="FF7844"/>
+                </a:solidFill>
+              </a:defRPr>
+            </a:pPr>
+            <a:r>
+              <a:t>🧠 Plain-English Jargon Buster (Gemma 4)</a:t>
             </a:r>
           </a:p>
           <a:p>
             <a:br/>
             <a:pPr>
-              <a:defRPr sz="1300">
+              <a:defRPr sz="1200">
                 <a:solidFill>
                   <a:srgbClr val="F0F6FC"/>
                 </a:solidFill>
               </a:defRPr>
             </a:pPr>
             <a:r>
-              <a:t>Gemma 4 simplifies complex issue threads into plain-English jargon-free concepts.</a:t>
+              <a:t>Translates dense, cryptic issue descriptions into accessible beginner explanations. Automatically extracts repository-specific jargon and generates a helpful glossary.</a:t>
             </a:r>
           </a:p>
         </p:txBody>
@@ -4139,8 +5219,8 @@
         </p:nvSpPr>
         <p:spPr>
           <a:xfrm>
-            <a:off x="5084064" y="1645920"/>
-            <a:ext cx="1993392" cy="4114800"/>
+            <a:off x="8046720" y="1645920"/>
+            <a:ext cx="3383280" cy="2148840"/>
           </a:xfrm>
           <a:prstGeom prst="roundRect">
             <a:avLst/>
@@ -4150,7 +5230,7 @@
           </a:solidFill>
           <a:ln>
             <a:solidFill>
-              <a:srgbClr val="A855F7"/>
+              <a:srgbClr val="30363D"/>
             </a:solidFill>
           </a:ln>
         </p:spPr>
@@ -4169,31 +5249,31 @@
           </a:fontRef>
         </p:style>
         <p:txBody>
-          <a:bodyPr rtlCol="0" anchor="ctr" wrap="square" lIns="182880" tIns="274320"/>
+          <a:bodyPr rtlCol="0" anchor="ctr" wrap="square" lIns="228600" tIns="182880"/>
           <a:lstStyle/>
           <a:p>
             <a:pPr algn="ctr">
-              <a:defRPr sz="1800" b="1">
+              <a:defRPr sz="1500" b="1">
                 <a:solidFill>
                   <a:srgbClr val="A855F7"/>
                 </a:solidFill>
               </a:defRPr>
             </a:pPr>
             <a:r>
-              <a:t>3. Plan</a:t>
+              <a:t>📁 Targeted File &amp; Component Mapping</a:t>
             </a:r>
           </a:p>
           <a:p>
             <a:br/>
             <a:pPr>
-              <a:defRPr sz="1300">
+              <a:defRPr sz="1200">
                 <a:solidFill>
                   <a:srgbClr val="F0F6FC"/>
                 </a:solidFill>
               </a:defRPr>
             </a:pPr>
             <a:r>
-              <a:t>Targeted file tree pointers + chronological step-by-step implementation plan.</a:t>
+              <a:t>Inspects the GitHub file tree to identify precisely which files and components require changes, eliminating analysis paralysis in massive codebases.</a:t>
             </a:r>
           </a:p>
         </p:txBody>
@@ -4206,8 +5286,8 @@
         </p:nvSpPr>
         <p:spPr>
           <a:xfrm>
-            <a:off x="7260336" y="1645920"/>
-            <a:ext cx="1993392" cy="4114800"/>
+            <a:off x="731520" y="4069080"/>
+            <a:ext cx="3383280" cy="2148840"/>
           </a:xfrm>
           <a:prstGeom prst="roundRect">
             <a:avLst/>
@@ -4217,7 +5297,7 @@
           </a:solidFill>
           <a:ln>
             <a:solidFill>
-              <a:srgbClr val="10B981"/>
+              <a:srgbClr val="30363D"/>
             </a:solidFill>
           </a:ln>
         </p:spPr>
@@ -4236,31 +5316,31 @@
           </a:fontRef>
         </p:style>
         <p:txBody>
-          <a:bodyPr rtlCol="0" anchor="ctr" wrap="square" lIns="182880" tIns="274320"/>
+          <a:bodyPr rtlCol="0" anchor="ctr" wrap="square" lIns="228600" tIns="182880"/>
           <a:lstStyle/>
           <a:p>
             <a:pPr algn="ctr">
-              <a:defRPr sz="1800" b="1">
+              <a:defRPr sz="1500" b="1">
                 <a:solidFill>
                   <a:srgbClr val="10B981"/>
                 </a:solidFill>
               </a:defRPr>
             </a:pPr>
             <a:r>
-              <a:t>4. Test</a:t>
+              <a:t>🛠️ Step-by-Step Implementation Roadmap</a:t>
             </a:r>
           </a:p>
           <a:p>
             <a:br/>
             <a:pPr>
-              <a:defRPr sz="1300">
+              <a:defRPr sz="1200">
                 <a:solidFill>
                   <a:srgbClr val="F0F6FC"/>
                 </a:solidFill>
               </a:defRPr>
             </a:pPr>
             <a:r>
-              <a:t>Auto-recommends test framework (pytest/Jest) &amp; scaffolds runnable unit test code.</a:t>
+              <a:t>Generates a structured, chronological blueprint: Environment setup, logic modifications, and verification steps so contributors know exactly what code to write.</a:t>
             </a:r>
           </a:p>
         </p:txBody>
@@ -4273,8 +5353,8 @@
         </p:nvSpPr>
         <p:spPr>
           <a:xfrm>
-            <a:off x="9436608" y="1645920"/>
-            <a:ext cx="1993392" cy="4114800"/>
+            <a:off x="4389120" y="4069080"/>
+            <a:ext cx="3383280" cy="2148840"/>
           </a:xfrm>
           <a:prstGeom prst="roundRect">
             <a:avLst/>
@@ -4284,7 +5364,7 @@
           </a:solidFill>
           <a:ln>
             <a:solidFill>
-              <a:srgbClr val="F0F6FC"/>
+              <a:srgbClr val="30363D"/>
             </a:solidFill>
           </a:ln>
         </p:spPr>
@@ -4303,31 +5383,98 @@
           </a:fontRef>
         </p:style>
         <p:txBody>
-          <a:bodyPr rtlCol="0" anchor="ctr" wrap="square" lIns="182880" tIns="274320"/>
+          <a:bodyPr rtlCol="0" anchor="ctr" wrap="square" lIns="228600" tIns="182880"/>
           <a:lstStyle/>
           <a:p>
             <a:pPr algn="ctr">
-              <a:defRPr sz="1800" b="1">
-                <a:solidFill>
-                  <a:srgbClr val="F0F6FC"/>
-                </a:solidFill>
-              </a:defRPr>
-            </a:pPr>
-            <a:r>
-              <a:t>5. Ship PR</a:t>
+              <a:defRPr sz="1500" b="1">
+                <a:solidFill>
+                  <a:srgbClr val="00F2FE"/>
+                </a:solidFill>
+              </a:defRPr>
+            </a:pPr>
+            <a:r>
+              <a:t>🧪 Unit Test Scaffolding &amp; Framework Suggestion</a:t>
             </a:r>
           </a:p>
           <a:p>
             <a:br/>
             <a:pPr>
-              <a:defRPr sz="1300">
+              <a:defRPr sz="1200">
                 <a:solidFill>
                   <a:srgbClr val="F0F6FC"/>
                 </a:solidFill>
               </a:defRPr>
             </a:pPr>
             <a:r>
-              <a:t>Generates professional PR description + interactive pre-flight PR readiness checklist.</a:t>
+              <a:t>Identifies the project's testing framework (pytest, Jest, Go test) and scaffolds runnable test cases with 1-click clipboard copy.</a:t>
+            </a:r>
+          </a:p>
+        </p:txBody>
+      </p:sp>
+      <p:sp>
+        <p:nvSpPr>
+          <p:cNvPr id="10" name="Rounded Rectangle 9"/>
+          <p:cNvSpPr/>
+          <p:nvPr/>
+        </p:nvSpPr>
+        <p:spPr>
+          <a:xfrm>
+            <a:off x="8046720" y="4069080"/>
+            <a:ext cx="3383280" cy="2148840"/>
+          </a:xfrm>
+          <a:prstGeom prst="roundRect">
+            <a:avLst/>
+          </a:prstGeom>
+          <a:solidFill>
+            <a:srgbClr val="161B22"/>
+          </a:solidFill>
+          <a:ln>
+            <a:solidFill>
+              <a:srgbClr val="30363D"/>
+            </a:solidFill>
+          </a:ln>
+        </p:spPr>
+        <p:style>
+          <a:lnRef idx="1">
+            <a:schemeClr val="accent1"/>
+          </a:lnRef>
+          <a:fillRef idx="3">
+            <a:schemeClr val="accent1"/>
+          </a:fillRef>
+          <a:effectRef idx="2">
+            <a:schemeClr val="accent1"/>
+          </a:effectRef>
+          <a:fontRef idx="minor">
+            <a:schemeClr val="lt1"/>
+          </a:fontRef>
+        </p:style>
+        <p:txBody>
+          <a:bodyPr rtlCol="0" anchor="ctr" wrap="square" lIns="228600" tIns="182880"/>
+          <a:lstStyle/>
+          <a:p>
+            <a:pPr algn="ctr">
+              <a:defRPr sz="1500" b="1">
+                <a:solidFill>
+                  <a:srgbClr val="FF7844"/>
+                </a:solidFill>
+              </a:defRPr>
+            </a:pPr>
+            <a:r>
+              <a:t>📝 PR Generator &amp; Pre-Flight Readiness Checklist</a:t>
+            </a:r>
+          </a:p>
+          <a:p>
+            <a:br/>
+            <a:pPr>
+              <a:defRPr sz="1200">
+                <a:solidFill>
+                  <a:srgbClr val="F0F6FC"/>
+                </a:solidFill>
+              </a:defRPr>
+            </a:pPr>
+            <a:r>
+              <a:t>Drafts a professional markdown PR description. Features an interactive pre-flight checklist modal that calculates a live readiness score before pushing code.</a:t>
             </a:r>
           </a:p>
         </p:txBody>
@@ -4402,7 +5549,7 @@
         <p:spPr>
           <a:xfrm>
             <a:off x="731520" y="365760"/>
-            <a:ext cx="10698480" cy="365760"/>
+            <a:ext cx="10698480" cy="320040"/>
           </a:xfrm>
           <a:prstGeom prst="rect">
             <a:avLst/>
@@ -4437,7 +5584,7 @@
         <p:spPr>
           <a:xfrm>
             <a:off x="731520" y="640080"/>
-            <a:ext cx="10698480" cy="731520"/>
+            <a:ext cx="10698480" cy="685800"/>
           </a:xfrm>
           <a:prstGeom prst="rect">
             <a:avLst/>
@@ -4451,14 +5598,14 @@
           <a:lstStyle/>
           <a:p>
             <a:pPr>
-              <a:defRPr sz="2800" b="1">
+              <a:defRPr sz="2600" b="1">
                 <a:solidFill>
                   <a:srgbClr val="F0F6FC"/>
                 </a:solidFill>
               </a:defRPr>
             </a:pPr>
             <a:r>
-              <a:t>System Architecture: Grounded Gemma 4 AI Layer</a:t>
+              <a:t>System Architecture: Decoupled &amp; Grounded AI Engine</a:t>
             </a:r>
           </a:p>
         </p:txBody>
@@ -4472,7 +5619,7 @@
         <p:spPr>
           <a:xfrm>
             <a:off x="731520" y="1645920"/>
-            <a:ext cx="5120640" cy="4572000"/>
+            <a:ext cx="3200400" cy="4389120"/>
           </a:xfrm>
           <a:prstGeom prst="roundRect">
             <a:avLst/>
@@ -4482,7 +5629,7 @@
           </a:solidFill>
           <a:ln>
             <a:solidFill>
-              <a:srgbClr val="30363D"/>
+              <a:srgbClr val="00F2FE"/>
             </a:solidFill>
           </a:ln>
         </p:spPr>
@@ -4501,84 +5648,172 @@
           </a:fontRef>
         </p:style>
         <p:txBody>
-          <a:bodyPr rtlCol="0" anchor="ctr" wrap="square" lIns="274320" tIns="274320"/>
+          <a:bodyPr rtlCol="0" anchor="ctr" lIns="274320" tIns="274320"/>
           <a:lstStyle/>
           <a:p>
             <a:pPr algn="ctr">
-              <a:defRPr sz="1800" b="1">
+              <a:defRPr sz="1600" b="1">
                 <a:solidFill>
                   <a:srgbClr val="00F2FE"/>
                 </a:solidFill>
               </a:defRPr>
             </a:pPr>
             <a:r>
-              <a:t>Decoupled Modern Stack</a:t>
-            </a:r>
-          </a:p>
-          <a:p>
+              <a:t>FRONTEND LAYER</a:t>
+            </a:r>
+          </a:p>
+          <a:p>
+            <a:br/>
             <a:pPr>
-              <a:defRPr b="1" sz="1300">
+              <a:defRPr sz="1500" b="1">
                 <a:solidFill>
                   <a:srgbClr val="F0F6FC"/>
                 </a:solidFill>
               </a:defRPr>
             </a:pPr>
             <a:r>
-              <a:t>• </a:t>
-            </a:r>
-            <a:br/>
-            <a:r>
-              <a:t>Next.js 14 Frontend: App Router, client-side session caching, responsive dark/light UI.</a:t>
+              <a:t>Next.js 14 (App Router)</a:t>
             </a:r>
           </a:p>
           <a:p>
             <a:pPr>
-              <a:defRPr b="1" sz="1300">
-                <a:solidFill>
-                  <a:srgbClr val="F0F6FC"/>
-                </a:solidFill>
-              </a:defRPr>
-            </a:pPr>
-            <a:r>
-              <a:t>• FastAPI Backend: Asynchronous Python service, strict Pydantic schemas, Uvicorn.</a:t>
+              <a:defRPr sz="1200">
+                <a:solidFill>
+                  <a:srgbClr val="8B949E"/>
+                </a:solidFill>
+              </a:defRPr>
+            </a:pPr>
+            <a:r>
+              <a:t>• React 18 &amp; CSS Modules</a:t>
             </a:r>
           </a:p>
           <a:p>
             <a:pPr>
-              <a:defRPr b="1" sz="1300">
-                <a:solidFill>
-                  <a:srgbClr val="F0F6FC"/>
-                </a:solidFill>
-              </a:defRPr>
-            </a:pPr>
-            <a:r>
-              <a:t>• GitHub REST API Client: Concurrent asyncio.gather requests, follow-redirects resilience.</a:t>
+              <a:defRPr sz="1200">
+                <a:solidFill>
+                  <a:srgbClr val="8B949E"/>
+                </a:solidFill>
+              </a:defRPr>
+            </a:pPr>
+            <a:r>
+              <a:t>• Dual Theme Engine (Dark/Light)</a:t>
             </a:r>
           </a:p>
           <a:p>
             <a:pPr>
-              <a:defRPr b="1" sz="1300">
-                <a:solidFill>
-                  <a:srgbClr val="F0F6FC"/>
-                </a:solidFill>
-              </a:defRPr>
-            </a:pPr>
-            <a:r>
-              <a:t>• Gemma 4 AI Service: Google AI Studio integration with dynamic discovery &amp; fallback.</a:t>
-            </a:r>
-          </a:p>
-        </p:txBody>
-      </p:sp>
-      <p:sp>
-        <p:nvSpPr>
-          <p:cNvPr id="6" name="Rounded Rectangle 5"/>
+              <a:defRPr sz="1200">
+                <a:solidFill>
+                  <a:srgbClr val="8B949E"/>
+                </a:solidFill>
+              </a:defRPr>
+            </a:pPr>
+            <a:r>
+              <a:t>• Keyboard Shortcuts ('/' search)</a:t>
+            </a:r>
+          </a:p>
+          <a:p>
+            <a:pPr>
+              <a:defRPr sz="1200">
+                <a:solidFill>
+                  <a:srgbClr val="8B949E"/>
+                </a:solidFill>
+              </a:defRPr>
+            </a:pPr>
+            <a:r>
+              <a:t>• Client sessionStorage Caching</a:t>
+            </a:r>
+          </a:p>
+          <a:p>
+            <a:pPr>
+              <a:defRPr sz="1200">
+                <a:solidFill>
+                  <a:srgbClr val="8B949E"/>
+                </a:solidFill>
+              </a:defRPr>
+            </a:pPr>
+            <a:r>
+              <a:t>• Interactive PR Checklist Modal</a:t>
+            </a:r>
+          </a:p>
+          <a:p>
+            <a:pPr>
+              <a:defRPr sz="1200">
+                <a:solidFill>
+                  <a:srgbClr val="8B949E"/>
+                </a:solidFill>
+              </a:defRPr>
+            </a:pPr>
+            <a:r>
+              <a:t>• Roadmap Export (.md &amp; PDF)</a:t>
+            </a:r>
+          </a:p>
+          <a:p>
+            <a:pPr>
+              <a:defRPr sz="1200">
+                <a:solidFill>
+                  <a:srgbClr val="8B949E"/>
+                </a:solidFill>
+              </a:defRPr>
+            </a:pPr>
+            <a:r>
+              <a:t>• Deployed on Vercel</a:t>
+            </a:r>
+          </a:p>
+        </p:txBody>
+      </p:sp>
+      <p:sp>
+        <p:nvSpPr>
+          <p:cNvPr id="6" name="Right Arrow 5"/>
           <p:cNvSpPr/>
           <p:nvPr/>
         </p:nvSpPr>
         <p:spPr>
           <a:xfrm>
-            <a:off x="6217920" y="1645920"/>
-            <a:ext cx="5212080" cy="4572000"/>
+            <a:off x="4023360" y="3474720"/>
+            <a:ext cx="457200" cy="365760"/>
+          </a:xfrm>
+          <a:prstGeom prst="rightArrow">
+            <a:avLst/>
+          </a:prstGeom>
+          <a:solidFill>
+            <a:srgbClr val="00F2FE"/>
+          </a:solidFill>
+          <a:ln>
+            <a:noFill/>
+          </a:ln>
+        </p:spPr>
+        <p:style>
+          <a:lnRef idx="1">
+            <a:schemeClr val="accent1"/>
+          </a:lnRef>
+          <a:fillRef idx="3">
+            <a:schemeClr val="accent1"/>
+          </a:fillRef>
+          <a:effectRef idx="2">
+            <a:schemeClr val="accent1"/>
+          </a:effectRef>
+          <a:fontRef idx="minor">
+            <a:schemeClr val="lt1"/>
+          </a:fontRef>
+        </p:style>
+        <p:txBody>
+          <a:bodyPr rtlCol="0" anchor="ctr"/>
+          <a:lstStyle/>
+          <a:p>
+            <a:pPr algn="ctr"/>
+          </a:p>
+        </p:txBody>
+      </p:sp>
+      <p:sp>
+        <p:nvSpPr>
+          <p:cNvPr id="7" name="Rounded Rectangle 6"/>
+          <p:cNvSpPr/>
+          <p:nvPr/>
+        </p:nvSpPr>
+        <p:spPr>
+          <a:xfrm>
+            <a:off x="4572000" y="1645920"/>
+            <a:ext cx="3291840" cy="4389120"/>
           </a:xfrm>
           <a:prstGeom prst="roundRect">
             <a:avLst/>
@@ -4607,31 +5842,31 @@
           </a:fontRef>
         </p:style>
         <p:txBody>
-          <a:bodyPr rtlCol="0" anchor="ctr" wrap="square" lIns="274320" tIns="274320"/>
+          <a:bodyPr rtlCol="0" anchor="ctr" lIns="274320" tIns="274320"/>
           <a:lstStyle/>
           <a:p>
             <a:pPr algn="ctr">
-              <a:defRPr sz="1800" b="1">
+              <a:defRPr sz="1600" b="1">
                 <a:solidFill>
                   <a:srgbClr val="FF7844"/>
                 </a:solidFill>
               </a:defRPr>
             </a:pPr>
             <a:r>
-              <a:t>How Gemma 4 Reasons (Grounded Context)</a:t>
+              <a:t>BACKEND SERVICE</a:t>
             </a:r>
           </a:p>
           <a:p>
             <a:br/>
             <a:pPr>
-              <a:defRPr b="1" sz="1400">
+              <a:defRPr sz="1500" b="1">
                 <a:solidFill>
                   <a:srgbClr val="F0F6FC"/>
                 </a:solidFill>
               </a:defRPr>
             </a:pPr>
             <a:r>
-              <a:t>1. Repository Tree Grounding</a:t>
+              <a:t>Python FastAPI &amp; Uvicorn</a:t>
             </a:r>
           </a:p>
           <a:p>
@@ -4643,57 +5878,246 @@
               </a:defRPr>
             </a:pPr>
             <a:r>
-              <a:t>Extracts verified directory structure to eliminate hallucinations of fake files.</a:t>
+              <a:t>• In-Memory TTL Cache (1h window)</a:t>
+            </a:r>
+          </a:p>
+          <a:p>
+            <a:pPr>
+              <a:defRPr sz="1200">
+                <a:solidFill>
+                  <a:srgbClr val="8B949E"/>
+                </a:solidFill>
+              </a:defRPr>
+            </a:pPr>
+            <a:r>
+              <a:t>• Parallel asyncio.gather fetches</a:t>
+            </a:r>
+          </a:p>
+          <a:p>
+            <a:pPr>
+              <a:defRPr sz="1200">
+                <a:solidFill>
+                  <a:srgbClr val="8B949E"/>
+                </a:solidFill>
+              </a:defRPr>
+            </a:pPr>
+            <a:r>
+              <a:t>• Worker Threadpool (non-blocking)</a:t>
+            </a:r>
+          </a:p>
+          <a:p>
+            <a:pPr>
+              <a:defRPr sz="1200">
+                <a:solidFill>
+                  <a:srgbClr val="8B949E"/>
+                </a:solidFill>
+              </a:defRPr>
+            </a:pPr>
+            <a:r>
+              <a:t>• Strict Pydantic Data Models</a:t>
+            </a:r>
+          </a:p>
+          <a:p>
+            <a:pPr>
+              <a:defRPr sz="1200">
+                <a:solidFill>
+                  <a:srgbClr val="8B949E"/>
+                </a:solidFill>
+              </a:defRPr>
+            </a:pPr>
+            <a:r>
+              <a:t>• CORS Wildcard Configuration</a:t>
+            </a:r>
+          </a:p>
+          <a:p>
+            <a:pPr>
+              <a:defRPr sz="1200">
+                <a:solidFill>
+                  <a:srgbClr val="8B949E"/>
+                </a:solidFill>
+              </a:defRPr>
+            </a:pPr>
+            <a:r>
+              <a:t>• Docker Containerized Service</a:t>
+            </a:r>
+          </a:p>
+          <a:p>
+            <a:pPr>
+              <a:defRPr sz="1200">
+                <a:solidFill>
+                  <a:srgbClr val="8B949E"/>
+                </a:solidFill>
+              </a:defRPr>
+            </a:pPr>
+            <a:r>
+              <a:t>• Deployed on Railway / Render</a:t>
+            </a:r>
+          </a:p>
+        </p:txBody>
+      </p:sp>
+      <p:sp>
+        <p:nvSpPr>
+          <p:cNvPr id="8" name="Right Arrow 7"/>
+          <p:cNvSpPr/>
+          <p:nvPr/>
+        </p:nvSpPr>
+        <p:spPr>
+          <a:xfrm>
+            <a:off x="7955279" y="3474720"/>
+            <a:ext cx="457200" cy="365760"/>
+          </a:xfrm>
+          <a:prstGeom prst="rightArrow">
+            <a:avLst/>
+          </a:prstGeom>
+          <a:solidFill>
+            <a:srgbClr val="FF7844"/>
+          </a:solidFill>
+          <a:ln>
+            <a:noFill/>
+          </a:ln>
+        </p:spPr>
+        <p:style>
+          <a:lnRef idx="1">
+            <a:schemeClr val="accent1"/>
+          </a:lnRef>
+          <a:fillRef idx="3">
+            <a:schemeClr val="accent1"/>
+          </a:fillRef>
+          <a:effectRef idx="2">
+            <a:schemeClr val="accent1"/>
+          </a:effectRef>
+          <a:fontRef idx="minor">
+            <a:schemeClr val="lt1"/>
+          </a:fontRef>
+        </p:style>
+        <p:txBody>
+          <a:bodyPr rtlCol="0" anchor="ctr"/>
+          <a:lstStyle/>
+          <a:p>
+            <a:pPr algn="ctr"/>
+          </a:p>
+        </p:txBody>
+      </p:sp>
+      <p:sp>
+        <p:nvSpPr>
+          <p:cNvPr id="9" name="Rounded Rectangle 8"/>
+          <p:cNvSpPr/>
+          <p:nvPr/>
+        </p:nvSpPr>
+        <p:spPr>
+          <a:xfrm>
+            <a:off x="8503920" y="1645920"/>
+            <a:ext cx="2926080" cy="4389120"/>
+          </a:xfrm>
+          <a:prstGeom prst="roundRect">
+            <a:avLst/>
+          </a:prstGeom>
+          <a:solidFill>
+            <a:srgbClr val="161B22"/>
+          </a:solidFill>
+          <a:ln>
+            <a:solidFill>
+              <a:srgbClr val="10B981"/>
+            </a:solidFill>
+          </a:ln>
+        </p:spPr>
+        <p:style>
+          <a:lnRef idx="1">
+            <a:schemeClr val="accent1"/>
+          </a:lnRef>
+          <a:fillRef idx="3">
+            <a:schemeClr val="accent1"/>
+          </a:fillRef>
+          <a:effectRef idx="2">
+            <a:schemeClr val="accent1"/>
+          </a:effectRef>
+          <a:fontRef idx="minor">
+            <a:schemeClr val="lt1"/>
+          </a:fontRef>
+        </p:style>
+        <p:txBody>
+          <a:bodyPr rtlCol="0" anchor="ctr" lIns="274320" tIns="274320"/>
+          <a:lstStyle/>
+          <a:p>
+            <a:pPr algn="ctr">
+              <a:defRPr sz="1600" b="1">
+                <a:solidFill>
+                  <a:srgbClr val="10B981"/>
+                </a:solidFill>
+              </a:defRPr>
+            </a:pPr>
+            <a:r>
+              <a:t>EXTERNAL / AI LAYER</a:t>
             </a:r>
           </a:p>
           <a:p>
             <a:br/>
             <a:pPr>
-              <a:defRPr b="1" sz="1400">
+              <a:defRPr sz="1400" b="1">
                 <a:solidFill>
                   <a:srgbClr val="F0F6FC"/>
                 </a:solidFill>
               </a:defRPr>
             </a:pPr>
             <a:r>
-              <a:t>2. Contributing &amp; Test Grounding</a:t>
+              <a:t>GitHub REST API v3</a:t>
             </a:r>
           </a:p>
           <a:p>
             <a:pPr>
-              <a:defRPr sz="1200">
+              <a:defRPr sz="1100">
                 <a:solidFill>
                   <a:srgbClr val="8B949E"/>
                 </a:solidFill>
               </a:defRPr>
             </a:pPr>
             <a:r>
-              <a:t>Ingests project manifests to recommend correct test frameworks (pytest, Jest, Go).</a:t>
+              <a:t>• Repository trees &amp; commits</a:t>
+            </a:r>
+            <a:br/>
+            <a:r>
+              <a:t>• Issues, labels, and guidelines</a:t>
+            </a:r>
+            <a:br/>
+            <a:r>
+              <a:t>• Auth token support (5k req/hr)</a:t>
             </a:r>
           </a:p>
           <a:p>
             <a:br/>
             <a:pPr>
-              <a:defRPr b="1" sz="1400">
+              <a:defRPr sz="1400" b="1">
                 <a:solidFill>
                   <a:srgbClr val="F0F6FC"/>
                 </a:solidFill>
               </a:defRPr>
             </a:pPr>
             <a:r>
-              <a:t>3. Structured Schema Parsing</a:t>
+              <a:t>Google AI Studio (Gemma 4)</a:t>
             </a:r>
           </a:p>
           <a:p>
             <a:pPr>
-              <a:defRPr sz="1200">
+              <a:defRPr sz="1100">
                 <a:solidFill>
                   <a:srgbClr val="8B949E"/>
                 </a:solidFill>
               </a:defRPr>
             </a:pPr>
             <a:r>
-              <a:t>Outputs strictly structured plans, jargon definitions, and PR descriptions for UI rendering.</a:t>
+              <a:t>• Real File Tree Grounding</a:t>
+            </a:r>
+            <a:br/>
+            <a:r>
+              <a:t>• Structured JSON Output Schemas</a:t>
+            </a:r>
+            <a:br/>
+            <a:r>
+              <a:t>• Dynamic Model Discovery</a:t>
+            </a:r>
+            <a:br/>
+            <a:r>
+              <a:t>• Automatic Gemini Flash Fallback</a:t>
             </a:r>
           </a:p>
         </p:txBody>
@@ -4768,7 +6192,7 @@
         <p:spPr>
           <a:xfrm>
             <a:off x="731520" y="365760"/>
-            <a:ext cx="10698480" cy="365760"/>
+            <a:ext cx="10698480" cy="320040"/>
           </a:xfrm>
           <a:prstGeom prst="rect">
             <a:avLst/>
@@ -4789,7 +6213,7 @@
               </a:defRPr>
             </a:pPr>
             <a:r>
-              <a:t>● BACKEND ARCHITECTURE</a:t>
+              <a:t>● SYSTEM WORKFLOW</a:t>
             </a:r>
           </a:p>
         </p:txBody>
@@ -4803,7 +6227,7 @@
         <p:spPr>
           <a:xfrm>
             <a:off x="731520" y="640080"/>
-            <a:ext cx="10698480" cy="731520"/>
+            <a:ext cx="10698480" cy="685800"/>
           </a:xfrm>
           <a:prstGeom prst="rect">
             <a:avLst/>
@@ -4817,14 +6241,14 @@
           <a:lstStyle/>
           <a:p>
             <a:pPr>
-              <a:defRPr sz="2800" b="1">
+              <a:defRPr sz="2600" b="1">
                 <a:solidFill>
                   <a:srgbClr val="F0F6FC"/>
                 </a:solidFill>
               </a:defRPr>
             </a:pPr>
             <a:r>
-              <a:t>Production Engineering: Speed, Caching &amp; Resilience</a:t>
+              <a:t>End-to-End System Workflow &amp; Technical Implementation</a:t>
             </a:r>
           </a:p>
         </p:txBody>
@@ -4838,7 +6262,417 @@
         <p:spPr>
           <a:xfrm>
             <a:off x="731520" y="1645920"/>
-            <a:ext cx="3383280" cy="3931920"/>
+            <a:ext cx="1645920" cy="2011680"/>
+          </a:xfrm>
+          <a:prstGeom prst="roundRect">
+            <a:avLst/>
+          </a:prstGeom>
+          <a:solidFill>
+            <a:srgbClr val="161B22"/>
+          </a:solidFill>
+          <a:ln>
+            <a:solidFill>
+              <a:srgbClr val="00F2FE"/>
+            </a:solidFill>
+          </a:ln>
+        </p:spPr>
+        <p:style>
+          <a:lnRef idx="1">
+            <a:schemeClr val="accent1"/>
+          </a:lnRef>
+          <a:fillRef idx="3">
+            <a:schemeClr val="accent1"/>
+          </a:fillRef>
+          <a:effectRef idx="2">
+            <a:schemeClr val="accent1"/>
+          </a:effectRef>
+          <a:fontRef idx="minor">
+            <a:schemeClr val="lt1"/>
+          </a:fontRef>
+        </p:style>
+        <p:txBody>
+          <a:bodyPr rtlCol="0" anchor="ctr" wrap="square" lIns="137160" tIns="182880"/>
+          <a:lstStyle/>
+          <a:p>
+            <a:pPr algn="ctr">
+              <a:defRPr sz="1200" b="1">
+                <a:solidFill>
+                  <a:srgbClr val="00F2FE"/>
+                </a:solidFill>
+              </a:defRPr>
+            </a:pPr>
+            <a:r>
+              <a:t>1. START / INPUT</a:t>
+            </a:r>
+          </a:p>
+          <a:p>
+            <a:br/>
+            <a:pPr>
+              <a:defRPr sz="1100">
+                <a:solidFill>
+                  <a:srgbClr val="F0F6FC"/>
+                </a:solidFill>
+              </a:defRPr>
+            </a:pPr>
+            <a:r>
+              <a:t>User enters public GitHub URL.</a:t>
+            </a:r>
+            <a:br/>
+            <a:r>
+              <a:t>(e.g., pallets/flask)</a:t>
+            </a:r>
+          </a:p>
+        </p:txBody>
+      </p:sp>
+      <p:sp>
+        <p:nvSpPr>
+          <p:cNvPr id="6" name="Rounded Rectangle 5"/>
+          <p:cNvSpPr/>
+          <p:nvPr/>
+        </p:nvSpPr>
+        <p:spPr>
+          <a:xfrm>
+            <a:off x="2542032" y="1645920"/>
+            <a:ext cx="1645920" cy="2011680"/>
+          </a:xfrm>
+          <a:prstGeom prst="roundRect">
+            <a:avLst/>
+          </a:prstGeom>
+          <a:solidFill>
+            <a:srgbClr val="161B22"/>
+          </a:solidFill>
+          <a:ln>
+            <a:solidFill>
+              <a:srgbClr val="A855F7"/>
+            </a:solidFill>
+          </a:ln>
+        </p:spPr>
+        <p:style>
+          <a:lnRef idx="1">
+            <a:schemeClr val="accent1"/>
+          </a:lnRef>
+          <a:fillRef idx="3">
+            <a:schemeClr val="accent1"/>
+          </a:fillRef>
+          <a:effectRef idx="2">
+            <a:schemeClr val="accent1"/>
+          </a:effectRef>
+          <a:fontRef idx="minor">
+            <a:schemeClr val="lt1"/>
+          </a:fontRef>
+        </p:style>
+        <p:txBody>
+          <a:bodyPr rtlCol="0" anchor="ctr" wrap="square" lIns="137160" tIns="182880"/>
+          <a:lstStyle/>
+          <a:p>
+            <a:pPr algn="ctr">
+              <a:defRPr sz="1200" b="1">
+                <a:solidFill>
+                  <a:srgbClr val="A855F7"/>
+                </a:solidFill>
+              </a:defRPr>
+            </a:pPr>
+            <a:r>
+              <a:t>2. CACHE CHECK</a:t>
+            </a:r>
+          </a:p>
+          <a:p>
+            <a:br/>
+            <a:pPr>
+              <a:defRPr sz="1100">
+                <a:solidFill>
+                  <a:srgbClr val="F0F6FC"/>
+                </a:solidFill>
+              </a:defRPr>
+            </a:pPr>
+            <a:r>
+              <a:t>FastAPI checks in-memory TTL cache.</a:t>
+            </a:r>
+            <a:br/>
+            <a:r>
+              <a:t>If hit: &lt;50ms return.</a:t>
+            </a:r>
+          </a:p>
+        </p:txBody>
+      </p:sp>
+      <p:sp>
+        <p:nvSpPr>
+          <p:cNvPr id="7" name="Rounded Rectangle 6"/>
+          <p:cNvSpPr/>
+          <p:nvPr/>
+        </p:nvSpPr>
+        <p:spPr>
+          <a:xfrm>
+            <a:off x="4352544" y="1645920"/>
+            <a:ext cx="1645920" cy="2011680"/>
+          </a:xfrm>
+          <a:prstGeom prst="roundRect">
+            <a:avLst/>
+          </a:prstGeom>
+          <a:solidFill>
+            <a:srgbClr val="161B22"/>
+          </a:solidFill>
+          <a:ln>
+            <a:solidFill>
+              <a:srgbClr val="FF7844"/>
+            </a:solidFill>
+          </a:ln>
+        </p:spPr>
+        <p:style>
+          <a:lnRef idx="1">
+            <a:schemeClr val="accent1"/>
+          </a:lnRef>
+          <a:fillRef idx="3">
+            <a:schemeClr val="accent1"/>
+          </a:fillRef>
+          <a:effectRef idx="2">
+            <a:schemeClr val="accent1"/>
+          </a:effectRef>
+          <a:fontRef idx="minor">
+            <a:schemeClr val="lt1"/>
+          </a:fontRef>
+        </p:style>
+        <p:txBody>
+          <a:bodyPr rtlCol="0" anchor="ctr" wrap="square" lIns="137160" tIns="182880"/>
+          <a:lstStyle/>
+          <a:p>
+            <a:pPr algn="ctr">
+              <a:defRPr sz="1200" b="1">
+                <a:solidFill>
+                  <a:srgbClr val="FF7844"/>
+                </a:solidFill>
+              </a:defRPr>
+            </a:pPr>
+            <a:r>
+              <a:t>3. CONCURRENT FETCH</a:t>
+            </a:r>
+          </a:p>
+          <a:p>
+            <a:br/>
+            <a:pPr>
+              <a:defRPr sz="1100">
+                <a:solidFill>
+                  <a:srgbClr val="F0F6FC"/>
+                </a:solidFill>
+              </a:defRPr>
+            </a:pPr>
+            <a:r>
+              <a:t>If miss: asyncio.gather pulls repo tree, issues &amp; guidelines.</a:t>
+            </a:r>
+          </a:p>
+        </p:txBody>
+      </p:sp>
+      <p:sp>
+        <p:nvSpPr>
+          <p:cNvPr id="8" name="Rounded Rectangle 7"/>
+          <p:cNvSpPr/>
+          <p:nvPr/>
+        </p:nvSpPr>
+        <p:spPr>
+          <a:xfrm>
+            <a:off x="6163056" y="1645920"/>
+            <a:ext cx="1645920" cy="2011680"/>
+          </a:xfrm>
+          <a:prstGeom prst="roundRect">
+            <a:avLst/>
+          </a:prstGeom>
+          <a:solidFill>
+            <a:srgbClr val="161B22"/>
+          </a:solidFill>
+          <a:ln>
+            <a:solidFill>
+              <a:srgbClr val="10B981"/>
+            </a:solidFill>
+          </a:ln>
+        </p:spPr>
+        <p:style>
+          <a:lnRef idx="1">
+            <a:schemeClr val="accent1"/>
+          </a:lnRef>
+          <a:fillRef idx="3">
+            <a:schemeClr val="accent1"/>
+          </a:fillRef>
+          <a:effectRef idx="2">
+            <a:schemeClr val="accent1"/>
+          </a:effectRef>
+          <a:fontRef idx="minor">
+            <a:schemeClr val="lt1"/>
+          </a:fontRef>
+        </p:style>
+        <p:txBody>
+          <a:bodyPr rtlCol="0" anchor="ctr" wrap="square" lIns="137160" tIns="182880"/>
+          <a:lstStyle/>
+          <a:p>
+            <a:pPr algn="ctr">
+              <a:defRPr sz="1200" b="1">
+                <a:solidFill>
+                  <a:srgbClr val="10B981"/>
+                </a:solidFill>
+              </a:defRPr>
+            </a:pPr>
+            <a:r>
+              <a:t>4. ISSUE TRIAGE</a:t>
+            </a:r>
+          </a:p>
+          <a:p>
+            <a:br/>
+            <a:pPr>
+              <a:defRPr sz="1100">
+                <a:solidFill>
+                  <a:srgbClr val="F0F6FC"/>
+                </a:solidFill>
+              </a:defRPr>
+            </a:pPr>
+            <a:r>
+              <a:t>Ranks issues by difficulty (Beginner, GSSoC) &amp; tech stack.</a:t>
+            </a:r>
+          </a:p>
+        </p:txBody>
+      </p:sp>
+      <p:sp>
+        <p:nvSpPr>
+          <p:cNvPr id="9" name="Rounded Rectangle 8"/>
+          <p:cNvSpPr/>
+          <p:nvPr/>
+        </p:nvSpPr>
+        <p:spPr>
+          <a:xfrm>
+            <a:off x="7973568" y="1645920"/>
+            <a:ext cx="1645920" cy="2011680"/>
+          </a:xfrm>
+          <a:prstGeom prst="roundRect">
+            <a:avLst/>
+          </a:prstGeom>
+          <a:solidFill>
+            <a:srgbClr val="161B22"/>
+          </a:solidFill>
+          <a:ln>
+            <a:solidFill>
+              <a:srgbClr val="00F2FE"/>
+            </a:solidFill>
+          </a:ln>
+        </p:spPr>
+        <p:style>
+          <a:lnRef idx="1">
+            <a:schemeClr val="accent1"/>
+          </a:lnRef>
+          <a:fillRef idx="3">
+            <a:schemeClr val="accent1"/>
+          </a:fillRef>
+          <a:effectRef idx="2">
+            <a:schemeClr val="accent1"/>
+          </a:effectRef>
+          <a:fontRef idx="minor">
+            <a:schemeClr val="lt1"/>
+          </a:fontRef>
+        </p:style>
+        <p:txBody>
+          <a:bodyPr rtlCol="0" anchor="ctr" wrap="square" lIns="137160" tIns="182880"/>
+          <a:lstStyle/>
+          <a:p>
+            <a:pPr algn="ctr">
+              <a:defRPr sz="1200" b="1">
+                <a:solidFill>
+                  <a:srgbClr val="00F2FE"/>
+                </a:solidFill>
+              </a:defRPr>
+            </a:pPr>
+            <a:r>
+              <a:t>5. GROUNDED AI</a:t>
+            </a:r>
+          </a:p>
+          <a:p>
+            <a:br/>
+            <a:pPr>
+              <a:defRPr sz="1100">
+                <a:solidFill>
+                  <a:srgbClr val="F0F6FC"/>
+                </a:solidFill>
+              </a:defRPr>
+            </a:pPr>
+            <a:r>
+              <a:t>Gemma 4 reasons with tree context in worker threadpool.</a:t>
+            </a:r>
+          </a:p>
+        </p:txBody>
+      </p:sp>
+      <p:sp>
+        <p:nvSpPr>
+          <p:cNvPr id="10" name="Rounded Rectangle 9"/>
+          <p:cNvSpPr/>
+          <p:nvPr/>
+        </p:nvSpPr>
+        <p:spPr>
+          <a:xfrm>
+            <a:off x="9784080" y="1645920"/>
+            <a:ext cx="1645920" cy="2011680"/>
+          </a:xfrm>
+          <a:prstGeom prst="roundRect">
+            <a:avLst/>
+          </a:prstGeom>
+          <a:solidFill>
+            <a:srgbClr val="161B22"/>
+          </a:solidFill>
+          <a:ln>
+            <a:solidFill>
+              <a:srgbClr val="FF7844"/>
+            </a:solidFill>
+          </a:ln>
+        </p:spPr>
+        <p:style>
+          <a:lnRef idx="1">
+            <a:schemeClr val="accent1"/>
+          </a:lnRef>
+          <a:fillRef idx="3">
+            <a:schemeClr val="accent1"/>
+          </a:fillRef>
+          <a:effectRef idx="2">
+            <a:schemeClr val="accent1"/>
+          </a:effectRef>
+          <a:fontRef idx="minor">
+            <a:schemeClr val="lt1"/>
+          </a:fontRef>
+        </p:style>
+        <p:txBody>
+          <a:bodyPr rtlCol="0" anchor="ctr" wrap="square" lIns="137160" tIns="182880"/>
+          <a:lstStyle/>
+          <a:p>
+            <a:pPr algn="ctr">
+              <a:defRPr sz="1200" b="1">
+                <a:solidFill>
+                  <a:srgbClr val="FF7844"/>
+                </a:solidFill>
+              </a:defRPr>
+            </a:pPr>
+            <a:r>
+              <a:t>6. OUTPUT HUB</a:t>
+            </a:r>
+          </a:p>
+          <a:p>
+            <a:br/>
+            <a:pPr>
+              <a:defRPr sz="1100">
+                <a:solidFill>
+                  <a:srgbClr val="F0F6FC"/>
+                </a:solidFill>
+              </a:defRPr>
+            </a:pPr>
+            <a:r>
+              <a:t>Renders Plan, File Pointers, Tests, and PR Draft.</a:t>
+            </a:r>
+          </a:p>
+        </p:txBody>
+      </p:sp>
+      <p:sp>
+        <p:nvSpPr>
+          <p:cNvPr id="11" name="Rounded Rectangle 10"/>
+          <p:cNvSpPr/>
+          <p:nvPr/>
+        </p:nvSpPr>
+        <p:spPr>
+          <a:xfrm>
+            <a:off x="731520" y="3931920"/>
+            <a:ext cx="3383280" cy="2377440"/>
           </a:xfrm>
           <a:prstGeom prst="roundRect">
             <a:avLst/>
@@ -4867,58 +6701,45 @@
           </a:fontRef>
         </p:style>
         <p:txBody>
-          <a:bodyPr rtlCol="0" anchor="ctr" wrap="square" lIns="274320" tIns="274320"/>
+          <a:bodyPr rtlCol="0" anchor="ctr" wrap="square" lIns="228600" tIns="228600"/>
           <a:lstStyle/>
           <a:p>
             <a:pPr algn="ctr">
-              <a:defRPr sz="2000" b="1">
+              <a:defRPr sz="1500" b="1">
                 <a:solidFill>
                   <a:srgbClr val="00F2FE"/>
                 </a:solidFill>
               </a:defRPr>
             </a:pPr>
             <a:r>
-              <a:t>⚡ 65% Latency Reduction</a:t>
+              <a:t>⚡ High-Performance Concurrency</a:t>
             </a:r>
           </a:p>
           <a:p>
             <a:br/>
             <a:pPr>
-              <a:defRPr sz="1600" b="1">
-                <a:solidFill>
-                  <a:srgbClr val="F0F6FC"/>
-                </a:solidFill>
-              </a:defRPr>
-            </a:pPr>
-            <a:r>
-              <a:t>Concurrent Async Fetching</a:t>
-            </a:r>
-          </a:p>
-          <a:p>
-            <a:br/>
-            <a:pPr>
-              <a:defRPr sz="1300">
+              <a:defRPr sz="1200">
                 <a:solidFill>
                   <a:srgbClr val="8B949E"/>
                 </a:solidFill>
               </a:defRPr>
             </a:pPr>
             <a:r>
-              <a:t>Replaced sequential GitHub API calls with asyncio.gather. Metadata, open issues, and file tree fetched simultaneously in &lt;1.8s.</a:t>
-            </a:r>
-          </a:p>
-        </p:txBody>
-      </p:sp>
-      <p:sp>
-        <p:nvSpPr>
-          <p:cNvPr id="6" name="Rounded Rectangle 5"/>
+              <a:t>All GitHub API endpoints (meta, languages, tree, issues) are gathered concurrently via httpx/asyncio. Synchronous Google AI SDK calls run inside asyncio.to_thread worker threadpools to keep the FastAPI event loop non-blocking.</a:t>
+            </a:r>
+          </a:p>
+        </p:txBody>
+      </p:sp>
+      <p:sp>
+        <p:nvSpPr>
+          <p:cNvPr id="12" name="Rounded Rectangle 11"/>
           <p:cNvSpPr/>
           <p:nvPr/>
         </p:nvSpPr>
         <p:spPr>
           <a:xfrm>
-            <a:off x="4389120" y="1645920"/>
-            <a:ext cx="3383280" cy="3931920"/>
+            <a:off x="4389120" y="3931920"/>
+            <a:ext cx="3383280" cy="2377440"/>
           </a:xfrm>
           <a:prstGeom prst="roundRect">
             <a:avLst/>
@@ -4947,58 +6768,45 @@
           </a:fontRef>
         </p:style>
         <p:txBody>
-          <a:bodyPr rtlCol="0" anchor="ctr" wrap="square" lIns="274320" tIns="274320"/>
+          <a:bodyPr rtlCol="0" anchor="ctr" wrap="square" lIns="228600" tIns="228600"/>
           <a:lstStyle/>
           <a:p>
             <a:pPr algn="ctr">
-              <a:defRPr sz="2000" b="1">
-                <a:solidFill>
-                  <a:srgbClr val="10B981"/>
-                </a:solidFill>
-              </a:defRPr>
-            </a:pPr>
-            <a:r>
-              <a:t>🛡️ Sub-50ms Repeat Loads</a:t>
+              <a:defRPr sz="1500" b="1">
+                <a:solidFill>
+                  <a:srgbClr val="FF7844"/>
+                </a:solidFill>
+              </a:defRPr>
+            </a:pPr>
+            <a:r>
+              <a:t>🛡️ Resilient Model Fallback</a:t>
             </a:r>
           </a:p>
           <a:p>
             <a:br/>
             <a:pPr>
-              <a:defRPr sz="1600" b="1">
-                <a:solidFill>
-                  <a:srgbClr val="F0F6FC"/>
-                </a:solidFill>
-              </a:defRPr>
-            </a:pPr>
-            <a:r>
-              <a:t>2-Tier Caching Architecture</a:t>
-            </a:r>
-          </a:p>
-          <a:p>
-            <a:br/>
-            <a:pPr>
-              <a:defRPr sz="1300">
+              <a:defRPr sz="1200">
                 <a:solidFill>
                   <a:srgbClr val="8B949E"/>
                 </a:solidFill>
               </a:defRPr>
             </a:pPr>
             <a:r>
-              <a:t>Client-side sessionStorage combined with an in-memory server TTL cache (1-hour window). Zero wasted GitHub rate limits.</a:t>
-            </a:r>
-          </a:p>
-        </p:txBody>
-      </p:sp>
-      <p:sp>
-        <p:nvSpPr>
-          <p:cNvPr id="7" name="Rounded Rectangle 6"/>
+              <a:t>The AI service dynamically queries available models on the active API key. If primary Gemma 4 faces upstream rate limiting, it automatically falls back across gemini-1.5-flash and gemini-pro transparently to the user.</a:t>
+            </a:r>
+          </a:p>
+        </p:txBody>
+      </p:sp>
+      <p:sp>
+        <p:nvSpPr>
+          <p:cNvPr id="13" name="Rounded Rectangle 12"/>
           <p:cNvSpPr/>
           <p:nvPr/>
         </p:nvSpPr>
         <p:spPr>
           <a:xfrm>
-            <a:off x="8046720" y="1645920"/>
-            <a:ext cx="3383280" cy="3931920"/>
+            <a:off x="8046720" y="3931920"/>
+            <a:ext cx="3383280" cy="2377440"/>
           </a:xfrm>
           <a:prstGeom prst="roundRect">
             <a:avLst/>
@@ -5027,98 +6835,31 @@
           </a:fontRef>
         </p:style>
         <p:txBody>
-          <a:bodyPr rtlCol="0" anchor="ctr" wrap="square" lIns="274320" tIns="274320"/>
+          <a:bodyPr rtlCol="0" anchor="ctr" wrap="square" lIns="228600" tIns="228600"/>
           <a:lstStyle/>
           <a:p>
             <a:pPr algn="ctr">
-              <a:defRPr sz="2000" b="1">
-                <a:solidFill>
-                  <a:srgbClr val="FF7844"/>
-                </a:solidFill>
-              </a:defRPr>
-            </a:pPr>
-            <a:r>
-              <a:t>🔄 99.9% Model Resilience</a:t>
+              <a:defRPr sz="1500" b="1">
+                <a:solidFill>
+                  <a:srgbClr val="10B981"/>
+                </a:solidFill>
+              </a:defRPr>
+            </a:pPr>
+            <a:r>
+              <a:t>📦 Two-Tier Intelligent Caching</a:t>
             </a:r>
           </a:p>
           <a:p>
             <a:br/>
             <a:pPr>
-              <a:defRPr sz="1600" b="1">
-                <a:solidFill>
-                  <a:srgbClr val="F0F6FC"/>
-                </a:solidFill>
-              </a:defRPr>
-            </a:pPr>
-            <a:r>
-              <a:t>Dynamic Discovery &amp; Fallback</a:t>
-            </a:r>
-          </a:p>
-          <a:p>
-            <a:br/>
-            <a:pPr>
-              <a:defRPr sz="1300">
+              <a:defRPr sz="1200">
                 <a:solidFill>
                   <a:srgbClr val="8B949E"/>
                 </a:solidFill>
               </a:defRPr>
             </a:pPr>
             <a:r>
-              <a:t>Backend discovers active models and executes seamless fallback across gemma-4, gemini-1.5-flash, and gemini-pro in worker threadpool.</a:t>
-            </a:r>
-          </a:p>
-        </p:txBody>
-      </p:sp>
-      <p:sp>
-        <p:nvSpPr>
-          <p:cNvPr id="8" name="Rounded Rectangle 7"/>
-          <p:cNvSpPr/>
-          <p:nvPr/>
-        </p:nvSpPr>
-        <p:spPr>
-          <a:xfrm>
-            <a:off x="731520" y="5760720"/>
-            <a:ext cx="10698480" cy="640080"/>
-          </a:xfrm>
-          <a:prstGeom prst="roundRect">
-            <a:avLst/>
-          </a:prstGeom>
-          <a:solidFill>
-            <a:srgbClr val="161B22"/>
-          </a:solidFill>
-          <a:ln>
-            <a:solidFill>
-              <a:srgbClr val="10B981"/>
-            </a:solidFill>
-          </a:ln>
-        </p:spPr>
-        <p:style>
-          <a:lnRef idx="1">
-            <a:schemeClr val="accent1"/>
-          </a:lnRef>
-          <a:fillRef idx="3">
-            <a:schemeClr val="accent1"/>
-          </a:fillRef>
-          <a:effectRef idx="2">
-            <a:schemeClr val="accent1"/>
-          </a:effectRef>
-          <a:fontRef idx="minor">
-            <a:schemeClr val="lt1"/>
-          </a:fontRef>
-        </p:style>
-        <p:txBody>
-          <a:bodyPr rtlCol="0" anchor="ctr"/>
-          <a:lstStyle/>
-          <a:p>
-            <a:pPr algn="ctr">
-              <a:defRPr sz="1200" b="1">
-                <a:solidFill>
-                  <a:srgbClr val="10B981"/>
-                </a:solidFill>
-              </a:defRPr>
-            </a:pPr>
-            <a:r>
-              <a:t>✅ Continuous Integration: Flake8 Linter + Pytest Unit Tests + Next.js Production Build automated on GitHub Actions</a:t>
+              <a:t>Browser sessionStorage caches analyzed repositories across user page transitions. Backend in-memory TTL cache (1-hour window) eliminates redundant GitHub API calls and protects rate limits.</a:t>
             </a:r>
           </a:p>
         </p:txBody>
@@ -5193,7 +6934,7 @@
         <p:spPr>
           <a:xfrm>
             <a:off x="731520" y="365760"/>
-            <a:ext cx="10698480" cy="365760"/>
+            <a:ext cx="10698480" cy="320040"/>
           </a:xfrm>
           <a:prstGeom prst="rect">
             <a:avLst/>
@@ -5214,7 +6955,7 @@
               </a:defRPr>
             </a:pPr>
             <a:r>
-              <a:t>● PRODUCT FEATURES</a:t>
+              <a:t>● CONTRIBUTION WORKFLOW</a:t>
             </a:r>
           </a:p>
         </p:txBody>
@@ -5228,7 +6969,7 @@
         <p:spPr>
           <a:xfrm>
             <a:off x="731520" y="640080"/>
-            <a:ext cx="10698480" cy="731520"/>
+            <a:ext cx="10698480" cy="685800"/>
           </a:xfrm>
           <a:prstGeom prst="rect">
             <a:avLst/>
@@ -5242,14 +6983,14 @@
           <a:lstStyle/>
           <a:p>
             <a:pPr>
-              <a:defRPr sz="2800" b="1">
+              <a:defRPr sz="2600" b="1">
                 <a:solidFill>
                   <a:srgbClr val="F0F6FC"/>
                 </a:solidFill>
               </a:defRPr>
             </a:pPr>
             <a:r>
-              <a:t>Contributor-First UX: Ergonomics That Drive Pull Requests</a:t>
+              <a:t>GitHub &amp; Hacktoberfest Contribution Lifecycle</a:t>
             </a:r>
           </a:p>
         </p:txBody>
@@ -5263,7 +7004,7 @@
         <p:spPr>
           <a:xfrm>
             <a:off x="731520" y="1645920"/>
-            <a:ext cx="3383280" cy="2011680"/>
+            <a:ext cx="2468880" cy="1920240"/>
           </a:xfrm>
           <a:prstGeom prst="roundRect">
             <a:avLst/>
@@ -5273,7 +7014,7 @@
           </a:solidFill>
           <a:ln>
             <a:solidFill>
-              <a:srgbClr val="30363D"/>
+              <a:srgbClr val="00F2FE"/>
             </a:solidFill>
           </a:ln>
         </p:spPr>
@@ -5292,31 +7033,31 @@
           </a:fontRef>
         </p:style>
         <p:txBody>
-          <a:bodyPr rtlCol="0" anchor="ctr" wrap="square" lIns="228600" tIns="228600"/>
+          <a:bodyPr rtlCol="0" anchor="ctr" wrap="square" lIns="182880" tIns="182880"/>
           <a:lstStyle/>
           <a:p>
             <a:pPr algn="ctr">
-              <a:defRPr sz="1600" b="1">
+              <a:defRPr sz="1400" b="1">
                 <a:solidFill>
                   <a:srgbClr val="00F2FE"/>
                 </a:solidFill>
               </a:defRPr>
             </a:pPr>
             <a:r>
-              <a:t>🔍 Smart Issue Triage</a:t>
+              <a:t>Step 1: Discover</a:t>
             </a:r>
           </a:p>
           <a:p>
             <a:br/>
             <a:pPr>
-              <a:defRPr sz="1300">
+              <a:defRPr sz="1200">
                 <a:solidFill>
                   <a:srgbClr val="F0F6FC"/>
                 </a:solidFill>
               </a:defRPr>
             </a:pPr>
             <a:r>
-              <a:t>Real-time search, difficulty rating pills, and GSSoC level filters.</a:t>
+              <a:t>Find target repo &amp; filter beginner-friendly issues in Copilot.</a:t>
             </a:r>
           </a:p>
         </p:txBody>
@@ -5329,8 +7070,8 @@
         </p:nvSpPr>
         <p:spPr>
           <a:xfrm>
-            <a:off x="4389120" y="1645920"/>
-            <a:ext cx="3383280" cy="2011680"/>
+            <a:off x="3474720" y="1645920"/>
+            <a:ext cx="2468880" cy="1920240"/>
           </a:xfrm>
           <a:prstGeom prst="roundRect">
             <a:avLst/>
@@ -5340,7 +7081,7 @@
           </a:solidFill>
           <a:ln>
             <a:solidFill>
-              <a:srgbClr val="30363D"/>
+              <a:srgbClr val="FF7844"/>
             </a:solidFill>
           </a:ln>
         </p:spPr>
@@ -5359,31 +7100,31 @@
           </a:fontRef>
         </p:style>
         <p:txBody>
-          <a:bodyPr rtlCol="0" anchor="ctr" wrap="square" lIns="228600" tIns="228600"/>
+          <a:bodyPr rtlCol="0" anchor="ctr" wrap="square" lIns="182880" tIns="182880"/>
           <a:lstStyle/>
           <a:p>
             <a:pPr algn="ctr">
-              <a:defRPr sz="1600" b="1">
+              <a:defRPr sz="1400" b="1">
                 <a:solidFill>
                   <a:srgbClr val="FF7844"/>
                 </a:solidFill>
               </a:defRPr>
             </a:pPr>
             <a:r>
-              <a:t>📖 Jargon Buster Glossary</a:t>
+              <a:t>Step 2: Understand</a:t>
             </a:r>
           </a:p>
           <a:p>
             <a:br/>
             <a:pPr>
-              <a:defRPr sz="1300">
+              <a:defRPr sz="1200">
                 <a:solidFill>
                   <a:srgbClr val="F0F6FC"/>
                 </a:solidFill>
               </a:defRPr>
             </a:pPr>
             <a:r>
-              <a:t>Translates intimidating technical domain terms into plain English.</a:t>
+              <a:t>Read Gemma 4 plain-English breakdown &amp; jargon glossary.</a:t>
             </a:r>
           </a:p>
         </p:txBody>
@@ -5396,8 +7137,8 @@
         </p:nvSpPr>
         <p:spPr>
           <a:xfrm>
-            <a:off x="8046720" y="1645920"/>
-            <a:ext cx="3383280" cy="2011680"/>
+            <a:off x="6217920" y="1645920"/>
+            <a:ext cx="2468880" cy="1920240"/>
           </a:xfrm>
           <a:prstGeom prst="roundRect">
             <a:avLst/>
@@ -5407,7 +7148,7 @@
           </a:solidFill>
           <a:ln>
             <a:solidFill>
-              <a:srgbClr val="30363D"/>
+              <a:srgbClr val="A855F7"/>
             </a:solidFill>
           </a:ln>
         </p:spPr>
@@ -5426,31 +7167,31 @@
           </a:fontRef>
         </p:style>
         <p:txBody>
-          <a:bodyPr rtlCol="0" anchor="ctr" wrap="square" lIns="228600" tIns="228600"/>
+          <a:bodyPr rtlCol="0" anchor="ctr" wrap="square" lIns="182880" tIns="182880"/>
           <a:lstStyle/>
           <a:p>
             <a:pPr algn="ctr">
-              <a:defRPr sz="1600" b="1">
+              <a:defRPr sz="1400" b="1">
                 <a:solidFill>
                   <a:srgbClr val="A855F7"/>
                 </a:solidFill>
               </a:defRPr>
             </a:pPr>
             <a:r>
-              <a:t>📁 Targeted File Tree</a:t>
+              <a:t>Step 3: Fork &amp; Clone</a:t>
             </a:r>
           </a:p>
           <a:p>
             <a:br/>
             <a:pPr>
-              <a:defRPr sz="1300">
+              <a:defRPr sz="1200">
                 <a:solidFill>
                   <a:srgbClr val="F0F6FC"/>
                 </a:solidFill>
               </a:defRPr>
             </a:pPr>
             <a:r>
-              <a:t>Points directly to exact files to modify, curing codebase confusion.</a:t>
+              <a:t>Fork repo on GitHub and clone locally to machine.</a:t>
             </a:r>
           </a:p>
         </p:txBody>
@@ -5463,8 +7204,8 @@
         </p:nvSpPr>
         <p:spPr>
           <a:xfrm>
-            <a:off x="731520" y="4023360"/>
-            <a:ext cx="3383280" cy="2011680"/>
+            <a:off x="8961120" y="1645920"/>
+            <a:ext cx="2468880" cy="1920240"/>
           </a:xfrm>
           <a:prstGeom prst="roundRect">
             <a:avLst/>
@@ -5474,7 +7215,7 @@
           </a:solidFill>
           <a:ln>
             <a:solidFill>
-              <a:srgbClr val="30363D"/>
+              <a:srgbClr val="10B981"/>
             </a:solidFill>
           </a:ln>
         </p:spPr>
@@ -5493,31 +7234,31 @@
           </a:fontRef>
         </p:style>
         <p:txBody>
-          <a:bodyPr rtlCol="0" anchor="ctr" wrap="square" lIns="228600" tIns="228600"/>
+          <a:bodyPr rtlCol="0" anchor="ctr" wrap="square" lIns="182880" tIns="182880"/>
           <a:lstStyle/>
           <a:p>
             <a:pPr algn="ctr">
-              <a:defRPr sz="1600" b="1">
+              <a:defRPr sz="1400" b="1">
                 <a:solidFill>
                   <a:srgbClr val="10B981"/>
                 </a:solidFill>
               </a:defRPr>
             </a:pPr>
             <a:r>
-              <a:t>🧪 Unit Test Scaffolding</a:t>
+              <a:t>Step 4: Branch</a:t>
             </a:r>
           </a:p>
           <a:p>
             <a:br/>
             <a:pPr>
-              <a:defRPr sz="1300">
+              <a:defRPr sz="1200">
                 <a:solidFill>
                   <a:srgbClr val="F0F6FC"/>
                 </a:solidFill>
               </a:defRPr>
             </a:pPr>
             <a:r>
-              <a:t>Auto-recommends test framework &amp; generates runnable test snippets.</a:t>
+              <a:t>Create a clean descriptive feature branch (`git checkout -b fix-123`).</a:t>
             </a:r>
           </a:p>
         </p:txBody>
@@ -5530,8 +7271,8 @@
         </p:nvSpPr>
         <p:spPr>
           <a:xfrm>
-            <a:off x="4389120" y="4023360"/>
-            <a:ext cx="3383280" cy="2011680"/>
+            <a:off x="731520" y="3794760"/>
+            <a:ext cx="2468880" cy="1920240"/>
           </a:xfrm>
           <a:prstGeom prst="roundRect">
             <a:avLst/>
@@ -5541,7 +7282,7 @@
           </a:solidFill>
           <a:ln>
             <a:solidFill>
-              <a:srgbClr val="30363D"/>
+              <a:srgbClr val="00F2FE"/>
             </a:solidFill>
           </a:ln>
         </p:spPr>
@@ -5560,31 +7301,31 @@
           </a:fontRef>
         </p:style>
         <p:txBody>
-          <a:bodyPr rtlCol="0" anchor="ctr" wrap="square" lIns="228600" tIns="228600"/>
+          <a:bodyPr rtlCol="0" anchor="ctr" wrap="square" lIns="182880" tIns="182880"/>
           <a:lstStyle/>
           <a:p>
             <a:pPr algn="ctr">
-              <a:defRPr sz="1600" b="1">
+              <a:defRPr sz="1400" b="1">
                 <a:solidFill>
                   <a:srgbClr val="00F2FE"/>
                 </a:solidFill>
               </a:defRPr>
             </a:pPr>
             <a:r>
-              <a:t>✅ PR Readiness Checklist</a:t>
+              <a:t>Step 5: Code Changes</a:t>
             </a:r>
           </a:p>
           <a:p>
             <a:br/>
             <a:pPr>
-              <a:defRPr sz="1300">
+              <a:defRPr sz="1200">
                 <a:solidFill>
                   <a:srgbClr val="F0F6FC"/>
                 </a:solidFill>
               </a:defRPr>
             </a:pPr>
             <a:r>
-              <a:t>Interactive pre-flight modal with live readiness score &amp; PR launcher.</a:t>
+              <a:t>Follow Copilot's targeted file pointers &amp; implementation steps.</a:t>
             </a:r>
           </a:p>
         </p:txBody>
@@ -5597,8 +7338,8 @@
         </p:nvSpPr>
         <p:spPr>
           <a:xfrm>
-            <a:off x="8046720" y="4023360"/>
-            <a:ext cx="3383280" cy="2011680"/>
+            <a:off x="3474720" y="3794760"/>
+            <a:ext cx="2468880" cy="1920240"/>
           </a:xfrm>
           <a:prstGeom prst="roundRect">
             <a:avLst/>
@@ -5608,7 +7349,7 @@
           </a:solidFill>
           <a:ln>
             <a:solidFill>
-              <a:srgbClr val="30363D"/>
+              <a:srgbClr val="FF7844"/>
             </a:solidFill>
           </a:ln>
         </p:spPr>
@@ -5627,31 +7368,219 @@
           </a:fontRef>
         </p:style>
         <p:txBody>
-          <a:bodyPr rtlCol="0" anchor="ctr" wrap="square" lIns="228600" tIns="228600"/>
+          <a:bodyPr rtlCol="0" anchor="ctr" wrap="square" lIns="182880" tIns="182880"/>
           <a:lstStyle/>
           <a:p>
             <a:pPr algn="ctr">
-              <a:defRPr sz="1600" b="1">
+              <a:defRPr sz="1400" b="1">
                 <a:solidFill>
                   <a:srgbClr val="FF7844"/>
                 </a:solidFill>
               </a:defRPr>
             </a:pPr>
             <a:r>
-              <a:t>📥 Roadmap Export</a:t>
+              <a:t>Step 6: Test &amp; Verify</a:t>
             </a:r>
           </a:p>
           <a:p>
             <a:br/>
             <a:pPr>
-              <a:defRPr sz="1300">
+              <a:defRPr sz="1200">
                 <a:solidFill>
                   <a:srgbClr val="F0F6FC"/>
                 </a:solidFill>
               </a:defRPr>
             </a:pPr>
             <a:r>
-              <a:t>1-click download of comprehensive roadmap as Markdown (.md) or printable PDF.</a:t>
+              <a:t>Run scaffolding tests using detected project test runner.</a:t>
+            </a:r>
+          </a:p>
+        </p:txBody>
+      </p:sp>
+      <p:sp>
+        <p:nvSpPr>
+          <p:cNvPr id="11" name="Rounded Rectangle 10"/>
+          <p:cNvSpPr/>
+          <p:nvPr/>
+        </p:nvSpPr>
+        <p:spPr>
+          <a:xfrm>
+            <a:off x="6217920" y="3794760"/>
+            <a:ext cx="2468880" cy="1920240"/>
+          </a:xfrm>
+          <a:prstGeom prst="roundRect">
+            <a:avLst/>
+          </a:prstGeom>
+          <a:solidFill>
+            <a:srgbClr val="161B22"/>
+          </a:solidFill>
+          <a:ln>
+            <a:solidFill>
+              <a:srgbClr val="A855F7"/>
+            </a:solidFill>
+          </a:ln>
+        </p:spPr>
+        <p:style>
+          <a:lnRef idx="1">
+            <a:schemeClr val="accent1"/>
+          </a:lnRef>
+          <a:fillRef idx="3">
+            <a:schemeClr val="accent1"/>
+          </a:fillRef>
+          <a:effectRef idx="2">
+            <a:schemeClr val="accent1"/>
+          </a:effectRef>
+          <a:fontRef idx="minor">
+            <a:schemeClr val="lt1"/>
+          </a:fontRef>
+        </p:style>
+        <p:txBody>
+          <a:bodyPr rtlCol="0" anchor="ctr" wrap="square" lIns="182880" tIns="182880"/>
+          <a:lstStyle/>
+          <a:p>
+            <a:pPr algn="ctr">
+              <a:defRPr sz="1400" b="1">
+                <a:solidFill>
+                  <a:srgbClr val="A855F7"/>
+                </a:solidFill>
+              </a:defRPr>
+            </a:pPr>
+            <a:r>
+              <a:t>Step 7: Pre-Flight Check</a:t>
+            </a:r>
+          </a:p>
+          <a:p>
+            <a:br/>
+            <a:pPr>
+              <a:defRPr sz="1200">
+                <a:solidFill>
+                  <a:srgbClr val="F0F6FC"/>
+                </a:solidFill>
+              </a:defRPr>
+            </a:pPr>
+            <a:r>
+              <a:t>Complete Copilot PR checklist: readiness score reaches 100%.</a:t>
+            </a:r>
+          </a:p>
+        </p:txBody>
+      </p:sp>
+      <p:sp>
+        <p:nvSpPr>
+          <p:cNvPr id="12" name="Rounded Rectangle 11"/>
+          <p:cNvSpPr/>
+          <p:nvPr/>
+        </p:nvSpPr>
+        <p:spPr>
+          <a:xfrm>
+            <a:off x="8961120" y="3794760"/>
+            <a:ext cx="2468880" cy="1920240"/>
+          </a:xfrm>
+          <a:prstGeom prst="roundRect">
+            <a:avLst/>
+          </a:prstGeom>
+          <a:solidFill>
+            <a:srgbClr val="161B22"/>
+          </a:solidFill>
+          <a:ln>
+            <a:solidFill>
+              <a:srgbClr val="10B981"/>
+            </a:solidFill>
+          </a:ln>
+        </p:spPr>
+        <p:style>
+          <a:lnRef idx="1">
+            <a:schemeClr val="accent1"/>
+          </a:lnRef>
+          <a:fillRef idx="3">
+            <a:schemeClr val="accent1"/>
+          </a:fillRef>
+          <a:effectRef idx="2">
+            <a:schemeClr val="accent1"/>
+          </a:effectRef>
+          <a:fontRef idx="minor">
+            <a:schemeClr val="lt1"/>
+          </a:fontRef>
+        </p:style>
+        <p:txBody>
+          <a:bodyPr rtlCol="0" anchor="ctr" wrap="square" lIns="182880" tIns="182880"/>
+          <a:lstStyle/>
+          <a:p>
+            <a:pPr algn="ctr">
+              <a:defRPr sz="1400" b="1">
+                <a:solidFill>
+                  <a:srgbClr val="10B981"/>
+                </a:solidFill>
+              </a:defRPr>
+            </a:pPr>
+            <a:r>
+              <a:t>Step 8: Open PR &amp; Merge</a:t>
+            </a:r>
+          </a:p>
+          <a:p>
+            <a:br/>
+            <a:pPr>
+              <a:defRPr sz="1200">
+                <a:solidFill>
+                  <a:srgbClr val="F0F6FC"/>
+                </a:solidFill>
+              </a:defRPr>
+            </a:pPr>
+            <a:r>
+              <a:t>1-click copy professional PR description and merge into upstream! 🎃</a:t>
+            </a:r>
+          </a:p>
+        </p:txBody>
+      </p:sp>
+      <p:sp>
+        <p:nvSpPr>
+          <p:cNvPr id="13" name="Rounded Rectangle 12"/>
+          <p:cNvSpPr/>
+          <p:nvPr/>
+        </p:nvSpPr>
+        <p:spPr>
+          <a:xfrm>
+            <a:off x="731520" y="5852160"/>
+            <a:ext cx="10698480" cy="594360"/>
+          </a:xfrm>
+          <a:prstGeom prst="roundRect">
+            <a:avLst/>
+          </a:prstGeom>
+          <a:solidFill>
+            <a:srgbClr val="161B22"/>
+          </a:solidFill>
+          <a:ln>
+            <a:solidFill>
+              <a:srgbClr val="10B981"/>
+            </a:solidFill>
+          </a:ln>
+        </p:spPr>
+        <p:style>
+          <a:lnRef idx="1">
+            <a:schemeClr val="accent1"/>
+          </a:lnRef>
+          <a:fillRef idx="3">
+            <a:schemeClr val="accent1"/>
+          </a:fillRef>
+          <a:effectRef idx="2">
+            <a:schemeClr val="accent1"/>
+          </a:effectRef>
+          <a:fontRef idx="minor">
+            <a:schemeClr val="lt1"/>
+          </a:fontRef>
+        </p:style>
+        <p:txBody>
+          <a:bodyPr rtlCol="0" anchor="ctr"/>
+          <a:lstStyle/>
+          <a:p>
+            <a:pPr algn="ctr">
+              <a:defRPr sz="1200" b="1">
+                <a:solidFill>
+                  <a:srgbClr val="10B981"/>
+                </a:solidFill>
+              </a:defRPr>
+            </a:pPr>
+            <a:r>
+              <a:t>🤝 Collaboration Pillars: Code Quality • Automated Testing • Transparent Documentation • Constructive Code Review</a:t>
             </a:r>
           </a:p>
         </p:txBody>
@@ -5726,7 +7655,7 @@
         <p:spPr>
           <a:xfrm>
             <a:off x="731520" y="365760"/>
-            <a:ext cx="10698480" cy="365760"/>
+            <a:ext cx="10698480" cy="320040"/>
           </a:xfrm>
           <a:prstGeom prst="rect">
             <a:avLst/>
@@ -5747,7 +7676,7 @@
               </a:defRPr>
             </a:pPr>
             <a:r>
-              <a:t>● PROJECT TRACTION</a:t>
+              <a:t>● IMPACT &amp; FUTURE SCOPE</a:t>
             </a:r>
           </a:p>
         </p:txBody>
@@ -5761,7 +7690,7 @@
         <p:spPr>
           <a:xfrm>
             <a:off x="731520" y="640080"/>
-            <a:ext cx="10698480" cy="731520"/>
+            <a:ext cx="10698480" cy="685800"/>
           </a:xfrm>
           <a:prstGeom prst="rect">
             <a:avLst/>
@@ -5775,14 +7704,14 @@
           <a:lstStyle/>
           <a:p>
             <a:pPr>
-              <a:defRPr sz="2800" b="1">
+              <a:defRPr sz="2600" b="1">
                 <a:solidFill>
                   <a:srgbClr val="F0F6FC"/>
                 </a:solidFill>
               </a:defRPr>
             </a:pPr>
             <a:r>
-              <a:t>Continuous Velocity &amp; Future Roadmap</a:t>
+              <a:t>Demonstrated Impact, Challenges &amp; Future Roadmap</a:t>
             </a:r>
           </a:p>
         </p:txBody>
@@ -5796,6 +7725,112 @@
         <p:spPr>
           <a:xfrm>
             <a:off x="731520" y="1645920"/>
+            <a:ext cx="5212080" cy="4572000"/>
+          </a:xfrm>
+          <a:prstGeom prst="roundRect">
+            <a:avLst/>
+          </a:prstGeom>
+          <a:solidFill>
+            <a:srgbClr val="161B22"/>
+          </a:solidFill>
+          <a:ln>
+            <a:solidFill>
+              <a:srgbClr val="00F2FE"/>
+            </a:solidFill>
+          </a:ln>
+        </p:spPr>
+        <p:style>
+          <a:lnRef idx="1">
+            <a:schemeClr val="accent1"/>
+          </a:lnRef>
+          <a:fillRef idx="3">
+            <a:schemeClr val="accent1"/>
+          </a:fillRef>
+          <a:effectRef idx="2">
+            <a:schemeClr val="accent1"/>
+          </a:effectRef>
+          <a:fontRef idx="minor">
+            <a:schemeClr val="lt1"/>
+          </a:fontRef>
+        </p:style>
+        <p:txBody>
+          <a:bodyPr rtlCol="0" anchor="ctr" lIns="274320" tIns="274320"/>
+          <a:lstStyle/>
+          <a:p>
+            <a:pPr algn="ctr">
+              <a:defRPr sz="1700" b="1">
+                <a:solidFill>
+                  <a:srgbClr val="00F2FE"/>
+                </a:solidFill>
+              </a:defRPr>
+            </a:pPr>
+            <a:r>
+              <a:t>Impact &amp; Technical Challenges Overcome</a:t>
+            </a:r>
+          </a:p>
+          <a:p>
+            <a:br/>
+            <a:pPr>
+              <a:defRPr sz="1200">
+                <a:solidFill>
+                  <a:srgbClr val="F0F6FC"/>
+                </a:solidFill>
+              </a:defRPr>
+            </a:pPr>
+            <a:r>
+              <a:t>• Community Impact: Democratizes open-source by turning high-friction issues into structured, accessible learning paths.</a:t>
+            </a:r>
+          </a:p>
+          <a:p>
+            <a:br/>
+            <a:pPr>
+              <a:defRPr sz="1200">
+                <a:solidFill>
+                  <a:srgbClr val="8B949E"/>
+                </a:solidFill>
+              </a:defRPr>
+            </a:pPr>
+            <a:r>
+              <a:t>• Challenge 1 (Rate Limits): GitHub anonymous limit is 60 req/hr. Solved by 2-tier TTL caching and authorization token support.</a:t>
+            </a:r>
+          </a:p>
+          <a:p>
+            <a:br/>
+            <a:pPr>
+              <a:defRPr sz="1200">
+                <a:solidFill>
+                  <a:srgbClr val="8B949E"/>
+                </a:solidFill>
+              </a:defRPr>
+            </a:pPr>
+            <a:r>
+              <a:t>• Challenge 2 (Hallucinations): Solved by feeding verified GitHub repository file trees into Gemma 4's system prompt constraints.</a:t>
+            </a:r>
+          </a:p>
+          <a:p>
+            <a:br/>
+            <a:pPr>
+              <a:defRPr sz="1200">
+                <a:solidFill>
+                  <a:srgbClr val="8B949E"/>
+                </a:solidFill>
+              </a:defRPr>
+            </a:pPr>
+            <a:r>
+              <a:t>• Challenge 3 (Inference Latency): Solved by asyncio.gather parallelization and threadpool worker execution.</a:t>
+            </a:r>
+          </a:p>
+        </p:txBody>
+      </p:sp>
+      <p:sp>
+        <p:nvSpPr>
+          <p:cNvPr id="6" name="Rounded Rectangle 5"/>
+          <p:cNvSpPr/>
+          <p:nvPr/>
+        </p:nvSpPr>
+        <p:spPr>
+          <a:xfrm>
+            <a:off x="6217920" y="1645920"/>
             <a:ext cx="5212080" cy="4572000"/>
           </a:xfrm>
           <a:prstGeom prst="roundRect">
@@ -5825,212 +7860,140 @@
           </a:fontRef>
         </p:style>
         <p:txBody>
-          <a:bodyPr rtlCol="0" anchor="ctr" wrap="square" lIns="274320" tIns="274320"/>
+          <a:bodyPr rtlCol="0" anchor="ctr" lIns="274320" tIns="274320"/>
           <a:lstStyle/>
           <a:p>
             <a:pPr algn="ctr">
-              <a:defRPr sz="1800" b="1">
+              <a:defRPr sz="1700" b="1">
                 <a:solidFill>
                   <a:srgbClr val="10B981"/>
                 </a:solidFill>
               </a:defRPr>
             </a:pPr>
             <a:r>
-              <a:t>Shipped in Round 2 (Active Commits)</a:t>
-            </a:r>
-          </a:p>
-          <a:p>
-            <a:pPr>
-              <a:defRPr b="1" sz="1300">
-                <a:solidFill>
-                  <a:srgbClr val="F0F6FC"/>
-                </a:solidFill>
-              </a:defRPr>
-            </a:pPr>
-            <a:br/>
-            <a:r>
-              <a:t>✓ Cloud Deployment: Live on Railway &amp; Vercel with zero-config failover.</a:t>
-            </a:r>
-          </a:p>
-          <a:p>
-            <a:pPr>
-              <a:defRPr b="1" sz="1300">
-                <a:solidFill>
-                  <a:srgbClr val="F0F6FC"/>
-                </a:solidFill>
-              </a:defRPr>
-            </a:pPr>
-            <a:br/>
-            <a:r>
-              <a:t>✓ Async Threadpool: Non-blocking Gemini generation in worker threadpool.</a:t>
-            </a:r>
-          </a:p>
-          <a:p>
-            <a:pPr>
-              <a:defRPr b="1" sz="1300">
-                <a:solidFill>
-                  <a:srgbClr val="F0F6FC"/>
-                </a:solidFill>
-              </a:defRPr>
-            </a:pPr>
-            <a:br/>
-            <a:r>
-              <a:t>✓ Dynamic Model Discovery: Transparent fallback across gemma-4 / gemini-flash.</a:t>
-            </a:r>
-          </a:p>
-          <a:p>
-            <a:pPr>
-              <a:defRPr b="1" sz="1300">
-                <a:solidFill>
-                  <a:srgbClr val="F0F6FC"/>
-                </a:solidFill>
-              </a:defRPr>
-            </a:pPr>
-            <a:br/>
-            <a:r>
-              <a:t>✓ Interactive PR Modal: Pre-flight compliance score &amp; live GitHub PR launcher.</a:t>
-            </a:r>
-          </a:p>
-          <a:p>
-            <a:pPr>
-              <a:defRPr b="1" sz="1300">
-                <a:solidFill>
-                  <a:srgbClr val="F0F6FC"/>
-                </a:solidFill>
-              </a:defRPr>
-            </a:pPr>
-            <a:br/>
-            <a:r>
-              <a:t>✓ Documentation &amp; CI: Postman Collection, Swagger API docs, automated CI.</a:t>
-            </a:r>
-          </a:p>
-        </p:txBody>
-      </p:sp>
-      <p:sp>
-        <p:nvSpPr>
-          <p:cNvPr id="6" name="Rounded Rectangle 5"/>
-          <p:cNvSpPr/>
-          <p:nvPr/>
-        </p:nvSpPr>
-        <p:spPr>
-          <a:xfrm>
-            <a:off x="6217920" y="1645920"/>
-            <a:ext cx="5212080" cy="4572000"/>
-          </a:xfrm>
-          <a:prstGeom prst="roundRect">
-            <a:avLst/>
-          </a:prstGeom>
-          <a:solidFill>
-            <a:srgbClr val="161B22"/>
-          </a:solidFill>
-          <a:ln>
-            <a:solidFill>
-              <a:srgbClr val="00F2FE"/>
-            </a:solidFill>
-          </a:ln>
-        </p:spPr>
-        <p:style>
-          <a:lnRef idx="1">
-            <a:schemeClr val="accent1"/>
-          </a:lnRef>
-          <a:fillRef idx="3">
-            <a:schemeClr val="accent1"/>
-          </a:fillRef>
-          <a:effectRef idx="2">
-            <a:schemeClr val="accent1"/>
-          </a:effectRef>
-          <a:fontRef idx="minor">
-            <a:schemeClr val="lt1"/>
-          </a:fontRef>
-        </p:style>
-        <p:txBody>
-          <a:bodyPr rtlCol="0" anchor="ctr" wrap="square" lIns="274320" tIns="274320"/>
-          <a:lstStyle/>
-          <a:p>
-            <a:pPr algn="ctr">
-              <a:defRPr sz="1800" b="1">
-                <a:solidFill>
-                  <a:srgbClr val="00F2FE"/>
-                </a:solidFill>
-              </a:defRPr>
-            </a:pPr>
-            <a:r>
-              <a:t>Future Roadmap (Post-Hackathon)</a:t>
+              <a:t>Roadmap: Completed vs Planned Scope</a:t>
             </a:r>
           </a:p>
           <a:p>
             <a:br/>
             <a:pPr>
-              <a:defRPr b="1" sz="1400">
+              <a:defRPr sz="1300" b="1">
                 <a:solidFill>
                   <a:srgbClr val="F0F6FC"/>
                 </a:solidFill>
               </a:defRPr>
             </a:pPr>
             <a:r>
-              <a:t>🚀 GitHub App / Bot</a:t>
+              <a:t>✅ Completed in Round 2 (Shipped):</a:t>
             </a:r>
           </a:p>
           <a:p>
             <a:pPr>
-              <a:defRPr sz="1200">
+              <a:defRPr sz="1100">
                 <a:solidFill>
                   <a:srgbClr val="8B949E"/>
                 </a:solidFill>
               </a:defRPr>
             </a:pPr>
             <a:r>
-              <a:t>Maintainers install a 1-click bot that mentors beginners automatically inside GitHub issue comments.</a:t>
+              <a:t>  ✓ Live Production Cloud Deployment (Railway + Vercel)</a:t>
+            </a:r>
+          </a:p>
+          <a:p>
+            <a:pPr>
+              <a:defRPr sz="1100">
+                <a:solidFill>
+                  <a:srgbClr val="8B949E"/>
+                </a:solidFill>
+              </a:defRPr>
+            </a:pPr>
+            <a:r>
+              <a:t>  ✓ Dynamic Model Discovery &amp; Threadpool Concurrency</a:t>
+            </a:r>
+          </a:p>
+          <a:p>
+            <a:pPr>
+              <a:defRPr sz="1100">
+                <a:solidFill>
+                  <a:srgbClr val="8B949E"/>
+                </a:solidFill>
+              </a:defRPr>
+            </a:pPr>
+            <a:r>
+              <a:t>  ✓ Interactive PR Checklist Modal with Live Readiness Score</a:t>
+            </a:r>
+          </a:p>
+          <a:p>
+            <a:pPr>
+              <a:defRPr sz="1100">
+                <a:solidFill>
+                  <a:srgbClr val="8B949E"/>
+                </a:solidFill>
+              </a:defRPr>
+            </a:pPr>
+            <a:r>
+              <a:t>  ✓ Roadmap Export (.md &amp; printable PDF)</a:t>
+            </a:r>
+          </a:p>
+          <a:p>
+            <a:pPr>
+              <a:defRPr sz="1100">
+                <a:solidFill>
+                  <a:srgbClr val="8B949E"/>
+                </a:solidFill>
+              </a:defRPr>
+            </a:pPr>
+            <a:r>
+              <a:t>  ✓ Automated CI/CD Pipeline (Flake8, Pytest, Next.js Build)</a:t>
             </a:r>
           </a:p>
           <a:p>
             <a:br/>
             <a:pPr>
-              <a:defRPr b="1" sz="1400">
-                <a:solidFill>
-                  <a:srgbClr val="F0F6FC"/>
-                </a:solidFill>
-              </a:defRPr>
-            </a:pPr>
-            <a:r>
-              <a:t>🚀 VS Code &amp; Cursor Extension</a:t>
+              <a:defRPr sz="1300" b="1">
+                <a:solidFill>
+                  <a:srgbClr val="FF7844"/>
+                </a:solidFill>
+              </a:defRPr>
+            </a:pPr>
+            <a:r>
+              <a:t>🔮 Planned Future Scope (Post-Hackathon):</a:t>
             </a:r>
           </a:p>
           <a:p>
             <a:pPr>
-              <a:defRPr sz="1200">
+              <a:defRPr sz="1100">
                 <a:solidFill>
                   <a:srgbClr val="8B949E"/>
                 </a:solidFill>
               </a:defRPr>
             </a:pPr>
             <a:r>
-              <a:t>Bring targeted file tree pointers and step-by-step guidance directly into developer IDEs.</a:t>
-            </a:r>
-          </a:p>
-          <a:p>
-            <a:br/>
+              <a:t>  • GitHub App / Bot: Auto-mentors contributors directly in issue comments.</a:t>
+            </a:r>
+          </a:p>
+          <a:p>
             <a:pPr>
-              <a:defRPr b="1" sz="1400">
-                <a:solidFill>
-                  <a:srgbClr val="F0F6FC"/>
-                </a:solidFill>
-              </a:defRPr>
-            </a:pPr>
-            <a:r>
-              <a:t>🚀 Program Dashboards</a:t>
+              <a:defRPr sz="1100">
+                <a:solidFill>
+                  <a:srgbClr val="8B949E"/>
+                </a:solidFill>
+              </a:defRPr>
+            </a:pPr>
+            <a:r>
+              <a:t>  • VS Code &amp; Cursor Extension: Brings file tree guidance into developer IDEs.</a:t>
             </a:r>
           </a:p>
           <a:p>
             <a:pPr>
-              <a:defRPr sz="1200">
+              <a:defRPr sz="1100">
                 <a:solidFill>
                   <a:srgbClr val="8B949E"/>
                 </a:solidFill>
               </a:defRPr>
             </a:pPr>
             <a:r>
-              <a:t>Partner with open-source programs (GSoC, Hacktoberfest) to track community contributor progression.</a:t>
+              <a:t>  • Maintainer Dashboards: Analytics on beginner issue resolution rates.</a:t>
             </a:r>
           </a:p>
         </p:txBody>
@@ -6105,7 +8068,7 @@
         <p:spPr>
           <a:xfrm>
             <a:off x="731520" y="365760"/>
-            <a:ext cx="10698480" cy="365760"/>
+            <a:ext cx="10698480" cy="320040"/>
           </a:xfrm>
           <a:prstGeom prst="rect">
             <a:avLst/>
@@ -6126,7 +8089,7 @@
               </a:defRPr>
             </a:pPr>
             <a:r>
-              <a:t>● CONCLUSION</a:t>
+              <a:t>● CONCLUSION &amp; CALL TO ACTION</a:t>
             </a:r>
           </a:p>
         </p:txBody>
@@ -6140,7 +8103,7 @@
         <p:spPr>
           <a:xfrm>
             <a:off x="731520" y="640080"/>
-            <a:ext cx="10698480" cy="731520"/>
+            <a:ext cx="10698480" cy="685800"/>
           </a:xfrm>
           <a:prstGeom prst="rect">
             <a:avLst/>
@@ -6154,14 +8117,14 @@
           <a:lstStyle/>
           <a:p>
             <a:pPr>
-              <a:defRPr sz="2800" b="1">
+              <a:defRPr sz="2600" b="1">
                 <a:solidFill>
                   <a:srgbClr val="F0F6FC"/>
                 </a:solidFill>
               </a:defRPr>
             </a:pPr>
             <a:r>
-              <a:t>Team GrandCoders &amp; Live Demonstration</a:t>
+              <a:t>Conclusion: Empowering the Next Generation of Builders</a:t>
             </a:r>
           </a:p>
         </p:txBody>
@@ -6175,7 +8138,7 @@
         <p:spPr>
           <a:xfrm>
             <a:off x="731520" y="1645920"/>
-            <a:ext cx="3383280" cy="2011680"/>
+            <a:ext cx="3383280" cy="1463040"/>
           </a:xfrm>
           <a:prstGeom prst="roundRect">
             <a:avLst/>
@@ -6204,11 +8167,11 @@
           </a:fontRef>
         </p:style>
         <p:txBody>
-          <a:bodyPr rtlCol="0" anchor="ctr" wrap="square" lIns="274320" tIns="274320"/>
+          <a:bodyPr rtlCol="0" anchor="ctr" wrap="square" lIns="228600" tIns="182880"/>
           <a:lstStyle/>
           <a:p>
             <a:pPr algn="ctr">
-              <a:defRPr sz="1800" b="1">
+              <a:defRPr sz="1700" b="1">
                 <a:solidFill>
                   <a:srgbClr val="F0F6FC"/>
                 </a:solidFill>
@@ -6242,7 +8205,7 @@
         <p:spPr>
           <a:xfrm>
             <a:off x="4389120" y="1645920"/>
-            <a:ext cx="3383280" cy="2011680"/>
+            <a:ext cx="3383280" cy="1463040"/>
           </a:xfrm>
           <a:prstGeom prst="roundRect">
             <a:avLst/>
@@ -6271,11 +8234,11 @@
           </a:fontRef>
         </p:style>
         <p:txBody>
-          <a:bodyPr rtlCol="0" anchor="ctr" wrap="square" lIns="274320" tIns="274320"/>
+          <a:bodyPr rtlCol="0" anchor="ctr" wrap="square" lIns="228600" tIns="182880"/>
           <a:lstStyle/>
           <a:p>
             <a:pPr algn="ctr">
-              <a:defRPr sz="1800" b="1">
+              <a:defRPr sz="1700" b="1">
                 <a:solidFill>
                   <a:srgbClr val="F0F6FC"/>
                 </a:solidFill>
@@ -6309,7 +8272,7 @@
         <p:spPr>
           <a:xfrm>
             <a:off x="8046720" y="1645920"/>
-            <a:ext cx="3383280" cy="2011680"/>
+            <a:ext cx="3383280" cy="1463040"/>
           </a:xfrm>
           <a:prstGeom prst="roundRect">
             <a:avLst/>
@@ -6338,11 +8301,11 @@
           </a:fontRef>
         </p:style>
         <p:txBody>
-          <a:bodyPr rtlCol="0" anchor="ctr" wrap="square" lIns="274320" tIns="274320"/>
+          <a:bodyPr rtlCol="0" anchor="ctr" wrap="square" lIns="228600" tIns="182880"/>
           <a:lstStyle/>
           <a:p>
             <a:pPr algn="ctr">
-              <a:defRPr sz="1800" b="1">
+              <a:defRPr sz="1700" b="1">
                 <a:solidFill>
                   <a:srgbClr val="F0F6FC"/>
                 </a:solidFill>
@@ -6375,14 +8338,104 @@
         </p:nvSpPr>
         <p:spPr>
           <a:xfrm>
-            <a:off x="731520" y="3931920"/>
-            <a:ext cx="10698480" cy="2286000"/>
+            <a:off x="731520" y="3291840"/>
+            <a:ext cx="10698480" cy="1554480"/>
           </a:xfrm>
           <a:prstGeom prst="roundRect">
             <a:avLst/>
           </a:prstGeom>
           <a:solidFill>
-            <a:srgbClr val="1E140F"/>
+            <a:srgbClr val="161B22"/>
+          </a:solidFill>
+          <a:ln>
+            <a:solidFill>
+              <a:srgbClr val="30363D"/>
+            </a:solidFill>
+          </a:ln>
+        </p:spPr>
+        <p:style>
+          <a:lnRef idx="1">
+            <a:schemeClr val="accent1"/>
+          </a:lnRef>
+          <a:fillRef idx="3">
+            <a:schemeClr val="accent1"/>
+          </a:fillRef>
+          <a:effectRef idx="2">
+            <a:schemeClr val="accent1"/>
+          </a:effectRef>
+          <a:fontRef idx="minor">
+            <a:schemeClr val="lt1"/>
+          </a:fontRef>
+        </p:style>
+        <p:txBody>
+          <a:bodyPr rtlCol="0" anchor="ctr" lIns="365760" tIns="182880"/>
+          <a:lstStyle/>
+          <a:p>
+            <a:pPr algn="ctr">
+              <a:defRPr sz="1600" b="1">
+                <a:solidFill>
+                  <a:srgbClr val="00F2FE"/>
+                </a:solidFill>
+              </a:defRPr>
+            </a:pPr>
+            <a:r>
+              <a:t>Key Project Takeaways:</a:t>
+            </a:r>
+          </a:p>
+          <a:p>
+            <a:pPr>
+              <a:defRPr sz="1300">
+                <a:solidFill>
+                  <a:srgbClr val="F0F6FC"/>
+                </a:solidFill>
+              </a:defRPr>
+            </a:pPr>
+            <a:r>
+              <a:t>1. Solves the Pre-Coding Barrier: Guides contributors from issue discovery to maintainer-ready PR.</a:t>
+            </a:r>
+          </a:p>
+          <a:p>
+            <a:pPr>
+              <a:defRPr sz="1300">
+                <a:solidFill>
+                  <a:srgbClr val="F0F6FC"/>
+                </a:solidFill>
+              </a:defRPr>
+            </a:pPr>
+            <a:r>
+              <a:t>2. Grounded AI Reasoning: Constrains Gemma 4 to verified repository file trees, eliminating hallucinations.</a:t>
+            </a:r>
+          </a:p>
+          <a:p>
+            <a:pPr>
+              <a:defRPr sz="1300">
+                <a:solidFill>
+                  <a:srgbClr val="F0F6FC"/>
+                </a:solidFill>
+              </a:defRPr>
+            </a:pPr>
+            <a:r>
+              <a:t>3. Production-Ready &amp; Deployed: High-performance caching, resilient fallbacks, and active CI/CD.</a:t>
+            </a:r>
+          </a:p>
+        </p:txBody>
+      </p:sp>
+      <p:sp>
+        <p:nvSpPr>
+          <p:cNvPr id="9" name="Rounded Rectangle 8"/>
+          <p:cNvSpPr/>
+          <p:nvPr/>
+        </p:nvSpPr>
+        <p:spPr>
+          <a:xfrm>
+            <a:off x="731520" y="4983480"/>
+            <a:ext cx="10698480" cy="1280160"/>
+          </a:xfrm>
+          <a:prstGeom prst="roundRect">
+            <a:avLst/>
+          </a:prstGeom>
+          <a:solidFill>
+            <a:srgbClr val="201612"/>
           </a:solidFill>
           <a:ln>
             <a:solidFill>
@@ -6405,44 +8458,42 @@
           </a:fontRef>
         </p:style>
         <p:txBody>
-          <a:bodyPr rtlCol="0" anchor="ctr" wrap="square" lIns="457200" tIns="365760"/>
+          <a:bodyPr rtlCol="0" anchor="ctr" tIns="182880"/>
           <a:lstStyle/>
           <a:p>
             <a:pPr algn="ctr">
-              <a:defRPr sz="2600" b="1">
+              <a:defRPr sz="2000" b="1">
                 <a:solidFill>
                   <a:srgbClr val="FF7844"/>
                 </a:solidFill>
               </a:defRPr>
             </a:pPr>
             <a:r>
-              <a:t>🎬 Let's See Hacktoberfest Copilot in Action!</a:t>
-            </a:r>
-          </a:p>
-          <a:p>
-            <a:br/>
-            <a:pPr algn="ctr">
-              <a:defRPr sz="1600">
-                <a:solidFill>
-                  <a:srgbClr val="F0F6FC"/>
-                </a:solidFill>
-              </a:defRPr>
-            </a:pPr>
-            <a:r>
-              <a:t>Live Walkthrough: Repo Analysis → Issue Triage → AI Guidance Hub → Unit Tests → PR Readiness</a:t>
-            </a:r>
-          </a:p>
-          <a:p>
-            <a:br/>
+              <a:t>“Build Together. Innovate Together. Open Source Forever.”</a:t>
+            </a:r>
+          </a:p>
+          <a:p>
             <a:pPr algn="ctr">
               <a:defRPr sz="1300">
                 <a:solidFill>
-                  <a:srgbClr val="8B949E"/>
-                </a:solidFill>
-              </a:defRPr>
-            </a:pPr>
-            <a:r>
-              <a:t>Repo: github.com/AsmitAnand/HacktoberFest-Team-GrandCoders  |  Base API: FastAPI on Railway</a:t>
+                  <a:srgbClr val="F0F6FC"/>
+                </a:solidFill>
+              </a:defRPr>
+            </a:pPr>
+            <a:r>
+              <a:t>Explore &amp; Star the Repo: github.com/AsmitAnand/HacktoberFest-Team-GrandCoders  |  FastAPI Backend Live on Railway</a:t>
+            </a:r>
+          </a:p>
+          <a:p>
+            <a:pPr algn="ctr">
+              <a:defRPr sz="1400" b="1">
+                <a:solidFill>
+                  <a:srgbClr val="00F2FE"/>
+                </a:solidFill>
+              </a:defRPr>
+            </a:pPr>
+            <a:r>
+              <a:t>🎬 Let's see Hacktoberfest Copilot in action — Over to the live demonstration!</a:t>
             </a:r>
           </a:p>
         </p:txBody>
@@ -6773,4 +8824,324 @@
   </a:objectDefaults>
   <a:extraClrSchemeLst/>
 </a:theme>
+</file>
+
+<file path=ppt/theme/theme2.xml><?xml version="1.0" encoding="utf-8"?>
+<a:theme xmlns:a="http://schemas.openxmlformats.org/drawingml/2006/main" name="Office Theme">
+  <a:themeElements>
+    <a:clrScheme name="Office">
+      <a:dk1>
+        <a:sysClr val="windowText" lastClr="000000"/>
+      </a:dk1>
+      <a:lt1>
+        <a:sysClr val="window" lastClr="FFFFFF"/>
+      </a:lt1>
+      <a:dk2>
+        <a:srgbClr val="1F497D"/>
+      </a:dk2>
+      <a:lt2>
+        <a:srgbClr val="EEECE1"/>
+      </a:lt2>
+      <a:accent1>
+        <a:srgbClr val="4F81BD"/>
+      </a:accent1>
+      <a:accent2>
+        <a:srgbClr val="C0504D"/>
+      </a:accent2>
+      <a:accent3>
+        <a:srgbClr val="9BBB59"/>
+      </a:accent3>
+      <a:accent4>
+        <a:srgbClr val="8064A2"/>
+      </a:accent4>
+      <a:accent5>
+        <a:srgbClr val="4BACC6"/>
+      </a:accent5>
+      <a:accent6>
+        <a:srgbClr val="F79646"/>
+      </a:accent6>
+      <a:hlink>
+        <a:srgbClr val="0000FF"/>
+      </a:hlink>
+      <a:folHlink>
+        <a:srgbClr val="800080"/>
+      </a:folHlink>
+    </a:clrScheme>
+    <a:fontScheme name="Office">
+      <a:majorFont>
+        <a:latin typeface="Calibri"/>
+        <a:ea typeface=""/>
+        <a:cs typeface=""/>
+        <a:font script="Jpan" typeface="ＭＳ Ｐゴシック"/>
+        <a:font script="Hang" typeface="맑은 고딕"/>
+        <a:font script="Hans" typeface="宋体"/>
+        <a:font script="Hant" typeface="新細明體"/>
+        <a:font script="Arab" typeface="Times New Roman"/>
+        <a:font script="Hebr" typeface="Times New Roman"/>
+        <a:font script="Thai" typeface="Angsana New"/>
+        <a:font script="Ethi" typeface="Nyala"/>
+        <a:font script="Beng" typeface="Vrinda"/>
+        <a:font script="Gujr" typeface="Shruti"/>
+        <a:font script="Khmr" typeface="MoolBoran"/>
+        <a:font script="Knda" typeface="Tunga"/>
+        <a:font script="Guru" typeface="Raavi"/>
+        <a:font script="Cans" typeface="Euphemia"/>
+        <a:font script="Cher" typeface="Plantagenet Cherokee"/>
+        <a:font script="Yiii" typeface="Microsoft Yi Baiti"/>
+        <a:font script="Tibt" typeface="Microsoft Himalaya"/>
+        <a:font script="Thaa" typeface="MV Boli"/>
+        <a:font script="Deva" typeface="Mangal"/>
+        <a:font script="Telu" typeface="Gautami"/>
+        <a:font script="Taml" typeface="Latha"/>
+        <a:font script="Syrc" typeface="Estrangelo Edessa"/>
+        <a:font script="Orya" typeface="Kalinga"/>
+        <a:font script="Mlym" typeface="Kartika"/>
+        <a:font script="Laoo" typeface="DokChampa"/>
+        <a:font script="Sinh" typeface="Iskoola Pota"/>
+        <a:font script="Mong" typeface="Mongolian Baiti"/>
+        <a:font script="Viet" typeface="Times New Roman"/>
+        <a:font script="Uigh" typeface="Microsoft Uighur"/>
+        <a:font script="Geor" typeface="Sylfaen"/>
+      </a:majorFont>
+      <a:minorFont>
+        <a:latin typeface="Calibri"/>
+        <a:ea typeface=""/>
+        <a:cs typeface=""/>
+        <a:font script="Jpan" typeface="ＭＳ Ｐゴシック"/>
+        <a:font script="Hang" typeface="맑은 고딕"/>
+        <a:font script="Hans" typeface="宋体"/>
+        <a:font script="Hant" typeface="新細明體"/>
+        <a:font script="Arab" typeface="Arial"/>
+        <a:font script="Hebr" typeface="Arial"/>
+        <a:font script="Thai" typeface="Cordia New"/>
+        <a:font script="Ethi" typeface="Nyala"/>
+        <a:font script="Beng" typeface="Vrinda"/>
+        <a:font script="Gujr" typeface="Shruti"/>
+        <a:font script="Khmr" typeface="DaunPenh"/>
+        <a:font script="Knda" typeface="Tunga"/>
+        <a:font script="Guru" typeface="Raavi"/>
+        <a:font script="Cans" typeface="Euphemia"/>
+        <a:font script="Cher" typeface="Plantagenet Cherokee"/>
+        <a:font script="Yiii" typeface="Microsoft Yi Baiti"/>
+        <a:font script="Tibt" typeface="Microsoft Himalaya"/>
+        <a:font script="Thaa" typeface="MV Boli"/>
+        <a:font script="Deva" typeface="Mangal"/>
+        <a:font script="Telu" typeface="Gautami"/>
+        <a:font script="Taml" typeface="Latha"/>
+        <a:font script="Syrc" typeface="Estrangelo Edessa"/>
+        <a:font script="Orya" typeface="Kalinga"/>
+        <a:font script="Mlym" typeface="Kartika"/>
+        <a:font script="Laoo" typeface="DokChampa"/>
+        <a:font script="Sinh" typeface="Iskoola Pota"/>
+        <a:font script="Mong" typeface="Mongolian Baiti"/>
+        <a:font script="Viet" typeface="Arial"/>
+        <a:font script="Uigh" typeface="Microsoft Uighur"/>
+        <a:font script="Geor" typeface="Sylfaen"/>
+      </a:minorFont>
+    </a:fontScheme>
+    <a:fmtScheme name="Office">
+      <a:fillStyleLst>
+        <a:solidFill>
+          <a:schemeClr val="phClr"/>
+        </a:solidFill>
+        <a:gradFill rotWithShape="1">
+          <a:gsLst>
+            <a:gs pos="0">
+              <a:schemeClr val="phClr">
+                <a:tint val="50000"/>
+                <a:satMod val="300000"/>
+              </a:schemeClr>
+            </a:gs>
+            <a:gs pos="35000">
+              <a:schemeClr val="phClr">
+                <a:tint val="37000"/>
+                <a:satMod val="300000"/>
+              </a:schemeClr>
+            </a:gs>
+            <a:gs pos="100000">
+              <a:schemeClr val="phClr">
+                <a:tint val="15000"/>
+                <a:satMod val="350000"/>
+              </a:schemeClr>
+            </a:gs>
+          </a:gsLst>
+          <a:lin ang="16200000" scaled="1"/>
+        </a:gradFill>
+        <a:gradFill rotWithShape="1">
+          <a:gsLst>
+            <a:gs pos="0">
+              <a:schemeClr val="phClr">
+                <a:tint val="100000"/>
+                <a:shade val="100000"/>
+                <a:satMod val="130000"/>
+              </a:schemeClr>
+            </a:gs>
+            <a:gs pos="100000">
+              <a:schemeClr val="phClr">
+                <a:tint val="50000"/>
+                <a:shade val="100000"/>
+                <a:satMod val="350000"/>
+              </a:schemeClr>
+            </a:gs>
+          </a:gsLst>
+          <a:lin ang="16200000" scaled="0"/>
+        </a:gradFill>
+      </a:fillStyleLst>
+      <a:lnStyleLst>
+        <a:ln w="9525" cap="flat" cmpd="sng" algn="ctr">
+          <a:solidFill>
+            <a:schemeClr val="phClr">
+              <a:shade val="95000"/>
+              <a:satMod val="105000"/>
+            </a:schemeClr>
+          </a:solidFill>
+          <a:prstDash val="solid"/>
+        </a:ln>
+        <a:ln w="25400" cap="flat" cmpd="sng" algn="ctr">
+          <a:solidFill>
+            <a:schemeClr val="phClr"/>
+          </a:solidFill>
+          <a:prstDash val="solid"/>
+        </a:ln>
+        <a:ln w="38100" cap="flat" cmpd="sng" algn="ctr">
+          <a:solidFill>
+            <a:schemeClr val="phClr"/>
+          </a:solidFill>
+          <a:prstDash val="solid"/>
+        </a:ln>
+      </a:lnStyleLst>
+      <a:effectStyleLst>
+        <a:effectStyle>
+          <a:effectLst>
+            <a:outerShdw blurRad="40000" dist="20000" dir="5400000" rotWithShape="0">
+              <a:srgbClr val="000000">
+                <a:alpha val="38000"/>
+              </a:srgbClr>
+            </a:outerShdw>
+          </a:effectLst>
+        </a:effectStyle>
+        <a:effectStyle>
+          <a:effectLst>
+            <a:outerShdw blurRad="40000" dist="23000" dir="5400000" rotWithShape="0">
+              <a:srgbClr val="000000">
+                <a:alpha val="35000"/>
+              </a:srgbClr>
+            </a:outerShdw>
+          </a:effectLst>
+        </a:effectStyle>
+        <a:effectStyle>
+          <a:effectLst>
+            <a:outerShdw blurRad="40000" dist="23000" dir="5400000" rotWithShape="0">
+              <a:srgbClr val="000000">
+                <a:alpha val="35000"/>
+              </a:srgbClr>
+            </a:outerShdw>
+          </a:effectLst>
+          <a:scene3d>
+            <a:camera prst="orthographicFront">
+              <a:rot lat="0" lon="0" rev="0"/>
+            </a:camera>
+            <a:lightRig rig="threePt" dir="t">
+              <a:rot lat="0" lon="0" rev="1200000"/>
+            </a:lightRig>
+          </a:scene3d>
+          <a:sp3d>
+            <a:bevelT w="63500" h="25400"/>
+          </a:sp3d>
+        </a:effectStyle>
+      </a:effectStyleLst>
+      <a:bgFillStyleLst>
+        <a:solidFill>
+          <a:schemeClr val="phClr"/>
+        </a:solidFill>
+        <a:gradFill rotWithShape="1">
+          <a:gsLst>
+            <a:gs pos="0">
+              <a:schemeClr val="phClr">
+                <a:tint val="40000"/>
+                <a:satMod val="350000"/>
+              </a:schemeClr>
+            </a:gs>
+            <a:gs pos="40000">
+              <a:schemeClr val="phClr">
+                <a:tint val="45000"/>
+                <a:shade val="99000"/>
+                <a:satMod val="350000"/>
+              </a:schemeClr>
+            </a:gs>
+            <a:gs pos="100000">
+              <a:schemeClr val="phClr">
+                <a:shade val="20000"/>
+                <a:satMod val="255000"/>
+              </a:schemeClr>
+            </a:gs>
+          </a:gsLst>
+          <a:path path="circle">
+            <a:fillToRect l="50000" t="-80000" r="50000" b="180000"/>
+          </a:path>
+        </a:gradFill>
+        <a:gradFill rotWithShape="1">
+          <a:gsLst>
+            <a:gs pos="0">
+              <a:schemeClr val="phClr">
+                <a:tint val="80000"/>
+                <a:satMod val="300000"/>
+              </a:schemeClr>
+            </a:gs>
+            <a:gs pos="100000">
+              <a:schemeClr val="phClr">
+                <a:shade val="30000"/>
+                <a:satMod val="200000"/>
+              </a:schemeClr>
+            </a:gs>
+          </a:gsLst>
+          <a:path path="circle">
+            <a:fillToRect l="50000" t="50000" r="50000" b="50000"/>
+          </a:path>
+        </a:gradFill>
+      </a:bgFillStyleLst>
+    </a:fmtScheme>
+  </a:themeElements>
+  <a:objectDefaults>
+    <a:spDef>
+      <a:spPr/>
+      <a:bodyPr/>
+      <a:lstStyle/>
+      <a:style>
+        <a:lnRef idx="1">
+          <a:schemeClr val="accent1"/>
+        </a:lnRef>
+        <a:fillRef idx="3">
+          <a:schemeClr val="accent1"/>
+        </a:fillRef>
+        <a:effectRef idx="2">
+          <a:schemeClr val="accent1"/>
+        </a:effectRef>
+        <a:fontRef idx="minor">
+          <a:schemeClr val="lt1"/>
+        </a:fontRef>
+      </a:style>
+    </a:spDef>
+    <a:lnDef>
+      <a:spPr/>
+      <a:bodyPr/>
+      <a:lstStyle/>
+      <a:style>
+        <a:lnRef idx="2">
+          <a:schemeClr val="accent1"/>
+        </a:lnRef>
+        <a:fillRef idx="0">
+          <a:schemeClr val="accent1"/>
+        </a:fillRef>
+        <a:effectRef idx="1">
+          <a:schemeClr val="accent1"/>
+        </a:effectRef>
+        <a:fontRef idx="minor">
+          <a:schemeClr val="tx1"/>
+        </a:fontRef>
+      </a:style>
+    </a:lnDef>
+  </a:objectDefaults>
+  <a:extraClrSchemeLst/>
+</a:theme>
 </file>
</xml_diff>

<commit_message>
feat(ui): add high-res developer mesh background, glassmorphism aesthetics, and fix default dark theme
</commit_message>
<xml_diff>
--- a/docs/Hacktoberfest_Copilot_Round2_Presentation.pptx
+++ b/docs/Hacktoberfest_Copilot_Round2_Presentation.pptx
@@ -7479,7 +7479,7 @@
         <p:spPr>
           <a:xfrm>
             <a:off x="731520" y="1645920"/>
-            <a:ext cx="2011680" cy="1005840"/>
+            <a:ext cx="2103120" cy="1005840"/>
           </a:xfrm>
           <a:prstGeom prst="roundRect">
             <a:avLst/>
@@ -7522,7 +7522,7 @@
             </a:r>
             <a:br/>
             <a:r>
-              <a:t>Enter GitHub Repo URL</a:t>
+              <a:t>User Enters GitHub URL</a:t>
             </a:r>
             <a:br/>
             <a:r>
@@ -7539,7 +7539,7 @@
         </p:nvSpPr>
         <p:spPr>
           <a:xfrm>
-            <a:off x="2788920" y="1965960"/>
+            <a:off x="2880360" y="2011680"/>
             <a:ext cx="365760" cy="274320"/>
           </a:xfrm>
           <a:prstGeom prst="rightArrow">
@@ -7576,16 +7576,16 @@
       </p:sp>
       <p:sp>
         <p:nvSpPr>
-          <p:cNvPr id="7" name="Diamond 6"/>
+          <p:cNvPr id="7" name="Rounded Rectangle 6"/>
           <p:cNvSpPr/>
           <p:nvPr/>
         </p:nvSpPr>
         <p:spPr>
           <a:xfrm>
-            <a:off x="3200400" y="1463040"/>
-            <a:ext cx="2103120" cy="1371600"/>
-          </a:xfrm>
-          <a:prstGeom prst="diamond">
+            <a:off x="3291840" y="1645920"/>
+            <a:ext cx="2286000" cy="1005840"/>
+          </a:xfrm>
+          <a:prstGeom prst="roundRect">
             <a:avLst/>
           </a:prstGeom>
           <a:solidFill>
@@ -7610,7 +7610,7 @@
           </a:fontRef>
         </p:style>
         <p:txBody>
-          <a:bodyPr rtlCol="0" anchor="ctr" tIns="274320"/>
+          <a:bodyPr rtlCol="0" anchor="ctr" tIns="137160"/>
           <a:lstStyle/>
           <a:p>
             <a:pPr algn="ctr">
@@ -7622,11 +7622,15 @@
               </a:defRPr>
             </a:pPr>
             <a:r>
-              <a:t>In-Memory</a:t>
+              <a:t>2. CACHE CHECK</a:t>
             </a:r>
             <a:br/>
             <a:r>
-              <a:t>TTL Cache Hit?</a:t>
+              <a:t>In-Memory TTL Hit?</a:t>
+            </a:r>
+            <a:br/>
+            <a:r>
+              <a:t>(&lt;50ms vs Network)</a:t>
             </a:r>
           </a:p>
         </p:txBody>
@@ -7639,7 +7643,7 @@
         </p:nvSpPr>
         <p:spPr>
           <a:xfrm>
-            <a:off x="4069080" y="2880360"/>
+            <a:off x="4297680" y="2697480"/>
             <a:ext cx="274320" cy="320040"/>
           </a:xfrm>
           <a:prstGeom prst="downArrow">
@@ -7682,8 +7686,8 @@
         </p:nvSpPr>
         <p:spPr>
           <a:xfrm>
-            <a:off x="3108960" y="3246120"/>
-            <a:ext cx="2286000" cy="777240"/>
+            <a:off x="3291840" y="3063240"/>
+            <a:ext cx="2286000" cy="548640"/>
           </a:xfrm>
           <a:prstGeom prst="roundRect">
             <a:avLst/>
@@ -7714,7 +7718,7 @@
           <a:lstStyle/>
           <a:p>
             <a:pPr algn="ctr">
-              <a:defRPr sz="1000" b="1">
+              <a:defRPr sz="900" b="1">
                 <a:solidFill>
                   <a:srgbClr val="FFFFFF"/>
                 </a:solidFill>
@@ -7722,7 +7726,7 @@
               </a:defRPr>
             </a:pPr>
             <a:r>
-              <a:t>⚡ FAST PATH: Return In-Memory Payload (&lt;50ms)</a:t>
+              <a:t>⚡ FAST PATH: Return In-Memory (&lt;50ms)</a:t>
             </a:r>
           </a:p>
         </p:txBody>
@@ -7735,7 +7739,7 @@
         </p:nvSpPr>
         <p:spPr>
           <a:xfrm>
-            <a:off x="5349240" y="1965960"/>
+            <a:off x="5623560" y="2011680"/>
             <a:ext cx="365760" cy="274320"/>
           </a:xfrm>
           <a:prstGeom prst="rightArrow">
@@ -7778,8 +7782,8 @@
         </p:nvSpPr>
         <p:spPr>
           <a:xfrm>
-            <a:off x="5760720" y="1645920"/>
-            <a:ext cx="2560320" cy="1005840"/>
+            <a:off x="6035040" y="1645920"/>
+            <a:ext cx="2743200" cy="1005840"/>
           </a:xfrm>
           <a:prstGeom prst="roundRect">
             <a:avLst/>
@@ -7822,7 +7826,11 @@
             </a:r>
             <a:br/>
             <a:r>
-              <a:t>asyncio.gather: Pulls Repo Tree, Issues &amp; Guidelines</a:t>
+              <a:t>asyncio.gather: Pulls Repo Tree,</a:t>
+            </a:r>
+            <a:br/>
+            <a:r>
+              <a:t>Open Issues &amp; Guidelines</a:t>
             </a:r>
           </a:p>
         </p:txBody>
@@ -7835,7 +7843,7 @@
         </p:nvSpPr>
         <p:spPr>
           <a:xfrm>
-            <a:off x="8366760" y="1965960"/>
+            <a:off x="8823960" y="2011680"/>
             <a:ext cx="365760" cy="274320"/>
           </a:xfrm>
           <a:prstGeom prst="rightArrow">
@@ -7878,8 +7886,8 @@
         </p:nvSpPr>
         <p:spPr>
           <a:xfrm>
-            <a:off x="8778240" y="1645920"/>
-            <a:ext cx="2651760" cy="1005840"/>
+            <a:off x="9235440" y="1645920"/>
+            <a:ext cx="2194560" cy="1005840"/>
           </a:xfrm>
           <a:prstGeom prst="roundRect">
             <a:avLst/>
@@ -7918,38 +7926,40 @@
               </a:defRPr>
             </a:pPr>
             <a:r>
-              <a:t>4. ISSUE TRIAGE</a:t>
+              <a:t>4. SMART TRIAGE</a:t>
             </a:r>
             <a:br/>
             <a:r>
-              <a:t>Categorizes by difficulty</a:t>
+              <a:t>Filters Beginner &amp; GSSoC;</a:t>
             </a:r>
             <a:br/>
             <a:r>
-              <a:t>(Beginner / GSSoC levels)</a:t>
-            </a:r>
-          </a:p>
-        </p:txBody>
-      </p:sp>
-      <p:sp>
-        <p:nvSpPr>
-          <p:cNvPr id="14" name="Down Arrow 13"/>
+              <a:t>Detects Tech Stack</a:t>
+            </a:r>
+          </a:p>
+        </p:txBody>
+      </p:sp>
+      <p:sp>
+        <p:nvSpPr>
+          <p:cNvPr id="14" name="Rounded Rectangle 13"/>
           <p:cNvSpPr/>
           <p:nvPr/>
         </p:nvSpPr>
         <p:spPr>
           <a:xfrm>
-            <a:off x="9966960" y="2743200"/>
-            <a:ext cx="320040" cy="411480"/>
-          </a:xfrm>
-          <a:prstGeom prst="downArrow">
-            <a:avLst/>
-          </a:prstGeom>
-          <a:solidFill>
-            <a:srgbClr val="0F172A"/>
-          </a:solidFill>
-          <a:ln>
-            <a:noFill/>
+            <a:off x="6400800" y="3063240"/>
+            <a:ext cx="5029200" cy="457200"/>
+          </a:xfrm>
+          <a:prstGeom prst="roundRect">
+            <a:avLst/>
+          </a:prstGeom>
+          <a:solidFill>
+            <a:srgbClr val="EFF6FF"/>
+          </a:solidFill>
+          <a:ln w="12700">
+            <a:solidFill>
+              <a:srgbClr val="1D4ED8"/>
+            </a:solidFill>
           </a:ln>
         </p:spPr>
         <p:style>
@@ -7970,7 +7980,17 @@
           <a:bodyPr rtlCol="0" anchor="ctr"/>
           <a:lstStyle/>
           <a:p>
-            <a:pPr algn="ctr"/>
+            <a:pPr algn="ctr">
+              <a:defRPr sz="1000" b="1">
+                <a:solidFill>
+                  <a:srgbClr val="1D4ED8"/>
+                </a:solidFill>
+                <a:latin typeface="Arial"/>
+              </a:defRPr>
+            </a:pPr>
+            <a:r>
+              <a:t>▼ Contributor Selects Issue ➔ Injects Repo File Tree Context</a:t>
+            </a:r>
           </a:p>
         </p:txBody>
       </p:sp>
@@ -7982,19 +8002,17 @@
         </p:nvSpPr>
         <p:spPr>
           <a:xfrm>
-            <a:off x="8778240" y="3291840"/>
-            <a:ext cx="2651760" cy="1005840"/>
+            <a:off x="731520" y="3840480"/>
+            <a:ext cx="2103120" cy="1005840"/>
           </a:xfrm>
           <a:prstGeom prst="roundRect">
             <a:avLst/>
           </a:prstGeom>
           <a:solidFill>
-            <a:srgbClr val="FFFFFF"/>
-          </a:solidFill>
-          <a:ln w="25400">
-            <a:solidFill>
-              <a:srgbClr val="1D4ED8"/>
-            </a:solidFill>
+            <a:srgbClr val="1D4ED8"/>
+          </a:solidFill>
+          <a:ln>
+            <a:noFill/>
           </a:ln>
         </p:spPr>
         <p:style>
@@ -8018,37 +8036,37 @@
             <a:pPr algn="ctr">
               <a:defRPr sz="1100" b="1">
                 <a:solidFill>
-                  <a:srgbClr val="0F172A"/>
-                </a:solidFill>
-                <a:latin typeface="Arial"/>
-              </a:defRPr>
-            </a:pPr>
-            <a:r>
-              <a:t>5. ISSUE SELECTION</a:t>
+                  <a:srgbClr val="FFFFFF"/>
+                </a:solidFill>
+                <a:latin typeface="Arial"/>
+              </a:defRPr>
+            </a:pPr>
+            <a:r>
+              <a:t>5. TREE GROUNDING</a:t>
             </a:r>
             <a:br/>
             <a:r>
-              <a:t>User chooses target issue.</a:t>
+              <a:t>Extracts verified file list;</a:t>
             </a:r>
             <a:br/>
             <a:r>
-              <a:t>Injects repo file tree context.</a:t>
-            </a:r>
-          </a:p>
-        </p:txBody>
-      </p:sp>
-      <p:sp>
-        <p:nvSpPr>
-          <p:cNvPr id="16" name="Left Arrow 15"/>
+              <a:t>Constrains system prompt</a:t>
+            </a:r>
+          </a:p>
+        </p:txBody>
+      </p:sp>
+      <p:sp>
+        <p:nvSpPr>
+          <p:cNvPr id="16" name="Right Arrow 15"/>
           <p:cNvSpPr/>
           <p:nvPr/>
         </p:nvSpPr>
         <p:spPr>
           <a:xfrm>
-            <a:off x="8366760" y="3657600"/>
+            <a:off x="2880360" y="4206240"/>
             <a:ext cx="365760" cy="274320"/>
           </a:xfrm>
-          <a:prstGeom prst="leftArrow">
+          <a:prstGeom prst="rightArrow">
             <a:avLst/>
           </a:prstGeom>
           <a:solidFill>
@@ -8082,16 +8100,16 @@
       </p:sp>
       <p:sp>
         <p:nvSpPr>
-          <p:cNvPr id="17" name="Diamond 16"/>
+          <p:cNvPr id="17" name="Rounded Rectangle 16"/>
           <p:cNvSpPr/>
           <p:nvPr/>
         </p:nvSpPr>
         <p:spPr>
           <a:xfrm>
-            <a:off x="6035040" y="3108960"/>
-            <a:ext cx="2286000" cy="1371600"/>
-          </a:xfrm>
-          <a:prstGeom prst="diamond">
+            <a:off x="3291840" y="3840480"/>
+            <a:ext cx="2286000" cy="1005840"/>
+          </a:xfrm>
+          <a:prstGeom prst="roundRect">
             <a:avLst/>
           </a:prstGeom>
           <a:solidFill>
@@ -8116,7 +8134,7 @@
           </a:fontRef>
         </p:style>
         <p:txBody>
-          <a:bodyPr rtlCol="0" anchor="ctr" tIns="320040"/>
+          <a:bodyPr rtlCol="0" anchor="ctr" tIns="137160"/>
           <a:lstStyle/>
           <a:p>
             <a:pPr algn="ctr">
@@ -8128,27 +8146,31 @@
               </a:defRPr>
             </a:pPr>
             <a:r>
-              <a:t>Gemma 4</a:t>
+              <a:t>6. GEMMA 4 INFERENCE</a:t>
             </a:r>
             <a:br/>
             <a:r>
-              <a:t>Available?</a:t>
-            </a:r>
-          </a:p>
-        </p:txBody>
-      </p:sp>
-      <p:sp>
-        <p:nvSpPr>
-          <p:cNvPr id="18" name="Left Arrow 17"/>
+              <a:t>Worker threadpool execution</a:t>
+            </a:r>
+            <a:br/>
+            <a:r>
+              <a:t>(Dynamic model fallback)</a:t>
+            </a:r>
+          </a:p>
+        </p:txBody>
+      </p:sp>
+      <p:sp>
+        <p:nvSpPr>
+          <p:cNvPr id="18" name="Right Arrow 17"/>
           <p:cNvSpPr/>
           <p:nvPr/>
         </p:nvSpPr>
         <p:spPr>
           <a:xfrm>
-            <a:off x="5623560" y="3657600"/>
+            <a:off x="5623560" y="4206240"/>
             <a:ext cx="365760" cy="274320"/>
           </a:xfrm>
-          <a:prstGeom prst="leftArrow">
+          <a:prstGeom prst="rightArrow">
             <a:avLst/>
           </a:prstGeom>
           <a:solidFill>
@@ -8188,8 +8210,8 @@
         </p:nvSpPr>
         <p:spPr>
           <a:xfrm>
-            <a:off x="3108960" y="4297680"/>
-            <a:ext cx="2468880" cy="1005840"/>
+            <a:off x="6035040" y="3840480"/>
+            <a:ext cx="2743200" cy="1005840"/>
           </a:xfrm>
           <a:prstGeom prst="roundRect">
             <a:avLst/>
@@ -8228,31 +8250,31 @@
               </a:defRPr>
             </a:pPr>
             <a:r>
-              <a:t>7. AI GUIDANCE HUB</a:t>
+              <a:t>7. GUIDANCE HUB OUTPUT</a:t>
             </a:r>
             <a:br/>
             <a:r>
-              <a:t>Plan, Target Files, Tests &amp;</a:t>
+              <a:t>Plain-English Plan, Target Files,</a:t>
             </a:r>
             <a:br/>
             <a:r>
-              <a:t>1-Click PR Description</a:t>
-            </a:r>
-          </a:p>
-        </p:txBody>
-      </p:sp>
-      <p:sp>
-        <p:nvSpPr>
-          <p:cNvPr id="20" name="Left Arrow 19"/>
+              <a:t>Unit Tests &amp; 1-Click PR Draft</a:t>
+            </a:r>
+          </a:p>
+        </p:txBody>
+      </p:sp>
+      <p:sp>
+        <p:nvSpPr>
+          <p:cNvPr id="20" name="Right Arrow 19"/>
           <p:cNvSpPr/>
           <p:nvPr/>
         </p:nvSpPr>
         <p:spPr>
           <a:xfrm>
-            <a:off x="2697480" y="4663440"/>
+            <a:off x="8823960" y="4206240"/>
             <a:ext cx="365760" cy="274320"/>
           </a:xfrm>
-          <a:prstGeom prst="leftArrow">
+          <a:prstGeom prst="rightArrow">
             <a:avLst/>
           </a:prstGeom>
           <a:solidFill>
@@ -8292,8 +8314,8 @@
         </p:nvSpPr>
         <p:spPr>
           <a:xfrm>
-            <a:off x="731520" y="4297680"/>
-            <a:ext cx="1920240" cy="1005840"/>
+            <a:off x="9235440" y="3840480"/>
+            <a:ext cx="2194560" cy="1005840"/>
           </a:xfrm>
           <a:prstGeom prst="roundRect">
             <a:avLst/>
@@ -8336,11 +8358,11 @@
             </a:r>
             <a:br/>
             <a:r>
-              <a:t>PR Checklist: 100%</a:t>
+              <a:t>PR Checklist: 100% Score</a:t>
             </a:r>
             <a:br/>
             <a:r>
-              <a:t>Ready to merge! 🎃</a:t>
+              <a:t>Ready for maintainer! 🎃</a:t>
             </a:r>
           </a:p>
         </p:txBody>
@@ -8353,8 +8375,8 @@
         </p:nvSpPr>
         <p:spPr>
           <a:xfrm>
-            <a:off x="731520" y="5577840"/>
-            <a:ext cx="10698480" cy="868680"/>
+            <a:off x="731520" y="5166360"/>
+            <a:ext cx="10698480" cy="1188720"/>
           </a:xfrm>
           <a:prstGeom prst="roundRect">
             <a:avLst/>
@@ -8383,7 +8405,7 @@
           </a:fontRef>
         </p:style>
         <p:txBody>
-          <a:bodyPr rtlCol="0" anchor="ctr" lIns="274320" tIns="109728"/>
+          <a:bodyPr rtlCol="0" anchor="ctr" lIns="274320" tIns="137160"/>
           <a:lstStyle/>
           <a:p>
             <a:pPr algn="ctr">

</xml_diff>